<commit_message>
Updated enterprise analytics project with advanced analytics and dashboard improvements
</commit_message>
<xml_diff>
--- a/Presentation/Enterprise_Sales_Analytics_Presentation.pptx
+++ b/Presentation/Enterprise_Sales_Analytics_Presentation.pptx
@@ -16,8 +16,9 @@
     <p:sldId id="264" r:id="rId10"/>
     <p:sldId id="265" r:id="rId11"/>
     <p:sldId id="266" r:id="rId12"/>
-    <p:sldId id="267" r:id="rId13"/>
-    <p:sldId id="268" r:id="rId14"/>
+    <p:sldId id="269" r:id="rId13"/>
+    <p:sldId id="267" r:id="rId14"/>
+    <p:sldId id="268" r:id="rId15"/>
   </p:sldIdLst>
   <p:sldSz cx="9144000" cy="6858000" type="screen4x3"/>
   <p:notesSz cx="6858000" cy="9144000"/>
@@ -300,7 +301,7 @@
           <a:p>
             <a:fld id="{5BCAD085-E8A6-8845-BD4E-CB4CCA059FC4}" type="datetimeFigureOut">
               <a:rPr lang="en-US" smtClean="0"/>
-              <a:t>7/1/2026</a:t>
+              <a:t>7/6/2026</a:t>
             </a:fld>
             <a:endParaRPr lang="en-US"/>
           </a:p>
@@ -358,13 +359,13 @@
   <p:clrMapOvr>
     <a:masterClrMapping/>
   </p:clrMapOvr>
-  <mc:AlternateContent xmlns:mc="http://schemas.openxmlformats.org/markup-compatibility/2006">
-    <mc:Choice xmlns:p14="http://schemas.microsoft.com/office/powerpoint/2010/main" Requires="p14">
+  <mc:AlternateContent xmlns:mc="http://schemas.openxmlformats.org/markup-compatibility/2006" xmlns:p14="http://schemas.microsoft.com/office/powerpoint/2010/main">
+    <mc:Choice Requires="p14">
       <p:transition spd="med" p14:dur="700">
         <p:fade/>
       </p:transition>
     </mc:Choice>
-    <mc:Fallback>
+    <mc:Fallback xmlns="">
       <p:transition spd="med">
         <p:fade/>
       </p:transition>
@@ -482,7 +483,7 @@
           <a:p>
             <a:fld id="{5BCAD085-E8A6-8845-BD4E-CB4CCA059FC4}" type="datetimeFigureOut">
               <a:rPr lang="en-US" smtClean="0"/>
-              <a:t>7/1/2026</a:t>
+              <a:t>7/6/2026</a:t>
             </a:fld>
             <a:endParaRPr lang="en-US"/>
           </a:p>
@@ -540,13 +541,13 @@
   <p:clrMapOvr>
     <a:masterClrMapping/>
   </p:clrMapOvr>
-  <mc:AlternateContent xmlns:mc="http://schemas.openxmlformats.org/markup-compatibility/2006">
-    <mc:Choice xmlns:p14="http://schemas.microsoft.com/office/powerpoint/2010/main" Requires="p14">
+  <mc:AlternateContent xmlns:mc="http://schemas.openxmlformats.org/markup-compatibility/2006" xmlns:p14="http://schemas.microsoft.com/office/powerpoint/2010/main">
+    <mc:Choice Requires="p14">
       <p:transition spd="med" p14:dur="700">
         <p:fade/>
       </p:transition>
     </mc:Choice>
-    <mc:Fallback>
+    <mc:Fallback xmlns="">
       <p:transition spd="med">
         <p:fade/>
       </p:transition>
@@ -674,7 +675,7 @@
           <a:p>
             <a:fld id="{5BCAD085-E8A6-8845-BD4E-CB4CCA059FC4}" type="datetimeFigureOut">
               <a:rPr lang="en-US" smtClean="0"/>
-              <a:t>7/1/2026</a:t>
+              <a:t>7/6/2026</a:t>
             </a:fld>
             <a:endParaRPr lang="en-US"/>
           </a:p>
@@ -732,13 +733,13 @@
   <p:clrMapOvr>
     <a:masterClrMapping/>
   </p:clrMapOvr>
-  <mc:AlternateContent xmlns:mc="http://schemas.openxmlformats.org/markup-compatibility/2006">
-    <mc:Choice xmlns:p14="http://schemas.microsoft.com/office/powerpoint/2010/main" Requires="p14">
+  <mc:AlternateContent xmlns:mc="http://schemas.openxmlformats.org/markup-compatibility/2006" xmlns:p14="http://schemas.microsoft.com/office/powerpoint/2010/main">
+    <mc:Choice Requires="p14">
       <p:transition spd="med" p14:dur="700">
         <p:fade/>
       </p:transition>
     </mc:Choice>
-    <mc:Fallback>
+    <mc:Fallback xmlns="">
       <p:transition spd="med">
         <p:fade/>
       </p:transition>
@@ -856,7 +857,7 @@
           <a:p>
             <a:fld id="{5BCAD085-E8A6-8845-BD4E-CB4CCA059FC4}" type="datetimeFigureOut">
               <a:rPr lang="en-US" smtClean="0"/>
-              <a:t>7/1/2026</a:t>
+              <a:t>7/6/2026</a:t>
             </a:fld>
             <a:endParaRPr lang="en-US"/>
           </a:p>
@@ -914,13 +915,13 @@
   <p:clrMapOvr>
     <a:masterClrMapping/>
   </p:clrMapOvr>
-  <mc:AlternateContent xmlns:mc="http://schemas.openxmlformats.org/markup-compatibility/2006">
-    <mc:Choice xmlns:p14="http://schemas.microsoft.com/office/powerpoint/2010/main" Requires="p14">
+  <mc:AlternateContent xmlns:mc="http://schemas.openxmlformats.org/markup-compatibility/2006" xmlns:p14="http://schemas.microsoft.com/office/powerpoint/2010/main">
+    <mc:Choice Requires="p14">
       <p:transition spd="med" p14:dur="700">
         <p:fade/>
       </p:transition>
     </mc:Choice>
-    <mc:Fallback>
+    <mc:Fallback xmlns="">
       <p:transition spd="med">
         <p:fade/>
       </p:transition>
@@ -1114,7 +1115,7 @@
           <a:p>
             <a:fld id="{5BCAD085-E8A6-8845-BD4E-CB4CCA059FC4}" type="datetimeFigureOut">
               <a:rPr lang="en-US" smtClean="0"/>
-              <a:t>7/1/2026</a:t>
+              <a:t>7/6/2026</a:t>
             </a:fld>
             <a:endParaRPr lang="en-US"/>
           </a:p>
@@ -1172,13 +1173,13 @@
   <p:clrMapOvr>
     <a:masterClrMapping/>
   </p:clrMapOvr>
-  <mc:AlternateContent xmlns:mc="http://schemas.openxmlformats.org/markup-compatibility/2006">
-    <mc:Choice xmlns:p14="http://schemas.microsoft.com/office/powerpoint/2010/main" Requires="p14">
+  <mc:AlternateContent xmlns:mc="http://schemas.openxmlformats.org/markup-compatibility/2006" xmlns:p14="http://schemas.microsoft.com/office/powerpoint/2010/main">
+    <mc:Choice Requires="p14">
       <p:transition spd="med" p14:dur="700">
         <p:fade/>
       </p:transition>
     </mc:Choice>
-    <mc:Fallback>
+    <mc:Fallback xmlns="">
       <p:transition spd="med">
         <p:fade/>
       </p:transition>
@@ -1414,7 +1415,7 @@
           <a:p>
             <a:fld id="{5BCAD085-E8A6-8845-BD4E-CB4CCA059FC4}" type="datetimeFigureOut">
               <a:rPr lang="en-US" smtClean="0"/>
-              <a:t>7/1/2026</a:t>
+              <a:t>7/6/2026</a:t>
             </a:fld>
             <a:endParaRPr lang="en-US"/>
           </a:p>
@@ -1472,13 +1473,13 @@
   <p:clrMapOvr>
     <a:masterClrMapping/>
   </p:clrMapOvr>
-  <mc:AlternateContent xmlns:mc="http://schemas.openxmlformats.org/markup-compatibility/2006">
-    <mc:Choice xmlns:p14="http://schemas.microsoft.com/office/powerpoint/2010/main" Requires="p14">
+  <mc:AlternateContent xmlns:mc="http://schemas.openxmlformats.org/markup-compatibility/2006" xmlns:p14="http://schemas.microsoft.com/office/powerpoint/2010/main">
+    <mc:Choice Requires="p14">
       <p:transition spd="med" p14:dur="700">
         <p:fade/>
       </p:transition>
     </mc:Choice>
-    <mc:Fallback>
+    <mc:Fallback xmlns="">
       <p:transition spd="med">
         <p:fade/>
       </p:transition>
@@ -1848,7 +1849,7 @@
           <a:p>
             <a:fld id="{5BCAD085-E8A6-8845-BD4E-CB4CCA059FC4}" type="datetimeFigureOut">
               <a:rPr lang="en-US" smtClean="0"/>
-              <a:t>7/1/2026</a:t>
+              <a:t>7/6/2026</a:t>
             </a:fld>
             <a:endParaRPr lang="en-US"/>
           </a:p>
@@ -1906,13 +1907,13 @@
   <p:clrMapOvr>
     <a:masterClrMapping/>
   </p:clrMapOvr>
-  <mc:AlternateContent xmlns:mc="http://schemas.openxmlformats.org/markup-compatibility/2006">
-    <mc:Choice xmlns:p14="http://schemas.microsoft.com/office/powerpoint/2010/main" Requires="p14">
+  <mc:AlternateContent xmlns:mc="http://schemas.openxmlformats.org/markup-compatibility/2006" xmlns:p14="http://schemas.microsoft.com/office/powerpoint/2010/main">
+    <mc:Choice Requires="p14">
       <p:transition spd="med" p14:dur="700">
         <p:fade/>
       </p:transition>
     </mc:Choice>
-    <mc:Fallback>
+    <mc:Fallback xmlns="">
       <p:transition spd="med">
         <p:fade/>
       </p:transition>
@@ -1978,7 +1979,7 @@
           <a:p>
             <a:fld id="{5BCAD085-E8A6-8845-BD4E-CB4CCA059FC4}" type="datetimeFigureOut">
               <a:rPr lang="en-US" smtClean="0"/>
-              <a:t>7/1/2026</a:t>
+              <a:t>7/6/2026</a:t>
             </a:fld>
             <a:endParaRPr lang="en-US"/>
           </a:p>
@@ -2036,13 +2037,13 @@
   <p:clrMapOvr>
     <a:masterClrMapping/>
   </p:clrMapOvr>
-  <mc:AlternateContent xmlns:mc="http://schemas.openxmlformats.org/markup-compatibility/2006">
-    <mc:Choice xmlns:p14="http://schemas.microsoft.com/office/powerpoint/2010/main" Requires="p14">
+  <mc:AlternateContent xmlns:mc="http://schemas.openxmlformats.org/markup-compatibility/2006" xmlns:p14="http://schemas.microsoft.com/office/powerpoint/2010/main">
+    <mc:Choice Requires="p14">
       <p:transition spd="med" p14:dur="700">
         <p:fade/>
       </p:transition>
     </mc:Choice>
-    <mc:Fallback>
+    <mc:Fallback xmlns="">
       <p:transition spd="med">
         <p:fade/>
       </p:transition>
@@ -2085,7 +2086,7 @@
           <a:p>
             <a:fld id="{5BCAD085-E8A6-8845-BD4E-CB4CCA059FC4}" type="datetimeFigureOut">
               <a:rPr lang="en-US" smtClean="0"/>
-              <a:t>7/1/2026</a:t>
+              <a:t>7/6/2026</a:t>
             </a:fld>
             <a:endParaRPr lang="en-US"/>
           </a:p>
@@ -2143,13 +2144,13 @@
   <p:clrMapOvr>
     <a:masterClrMapping/>
   </p:clrMapOvr>
-  <mc:AlternateContent xmlns:mc="http://schemas.openxmlformats.org/markup-compatibility/2006">
-    <mc:Choice xmlns:p14="http://schemas.microsoft.com/office/powerpoint/2010/main" Requires="p14">
+  <mc:AlternateContent xmlns:mc="http://schemas.openxmlformats.org/markup-compatibility/2006" xmlns:p14="http://schemas.microsoft.com/office/powerpoint/2010/main">
+    <mc:Choice Requires="p14">
       <p:transition spd="med" p14:dur="700">
         <p:fade/>
       </p:transition>
     </mc:Choice>
-    <mc:Fallback>
+    <mc:Fallback xmlns="">
       <p:transition spd="med">
         <p:fade/>
       </p:transition>
@@ -2374,7 +2375,7 @@
           <a:p>
             <a:fld id="{5BCAD085-E8A6-8845-BD4E-CB4CCA059FC4}" type="datetimeFigureOut">
               <a:rPr lang="en-US" smtClean="0"/>
-              <a:t>7/1/2026</a:t>
+              <a:t>7/6/2026</a:t>
             </a:fld>
             <a:endParaRPr lang="en-US"/>
           </a:p>
@@ -2432,13 +2433,13 @@
   <p:clrMapOvr>
     <a:masterClrMapping/>
   </p:clrMapOvr>
-  <mc:AlternateContent xmlns:mc="http://schemas.openxmlformats.org/markup-compatibility/2006">
-    <mc:Choice xmlns:p14="http://schemas.microsoft.com/office/powerpoint/2010/main" Requires="p14">
+  <mc:AlternateContent xmlns:mc="http://schemas.openxmlformats.org/markup-compatibility/2006" xmlns:p14="http://schemas.microsoft.com/office/powerpoint/2010/main">
+    <mc:Choice Requires="p14">
       <p:transition spd="med" p14:dur="700">
         <p:fade/>
       </p:transition>
     </mc:Choice>
-    <mc:Fallback>
+    <mc:Fallback xmlns="">
       <p:transition spd="med">
         <p:fade/>
       </p:transition>
@@ -2639,7 +2640,7 @@
           <a:p>
             <a:fld id="{5BCAD085-E8A6-8845-BD4E-CB4CCA059FC4}" type="datetimeFigureOut">
               <a:rPr lang="en-US" smtClean="0"/>
-              <a:t>7/1/2026</a:t>
+              <a:t>7/6/2026</a:t>
             </a:fld>
             <a:endParaRPr lang="en-US"/>
           </a:p>
@@ -2697,13 +2698,13 @@
   <p:clrMapOvr>
     <a:masterClrMapping/>
   </p:clrMapOvr>
-  <mc:AlternateContent xmlns:mc="http://schemas.openxmlformats.org/markup-compatibility/2006">
-    <mc:Choice xmlns:p14="http://schemas.microsoft.com/office/powerpoint/2010/main" Requires="p14">
+  <mc:AlternateContent xmlns:mc="http://schemas.openxmlformats.org/markup-compatibility/2006" xmlns:p14="http://schemas.microsoft.com/office/powerpoint/2010/main">
+    <mc:Choice Requires="p14">
       <p:transition spd="med" p14:dur="700">
         <p:fade/>
       </p:transition>
     </mc:Choice>
-    <mc:Fallback>
+    <mc:Fallback xmlns="">
       <p:transition spd="med">
         <p:fade/>
       </p:transition>
@@ -2864,7 +2865,7 @@
           <a:p>
             <a:fld id="{5BCAD085-E8A6-8845-BD4E-CB4CCA059FC4}" type="datetimeFigureOut">
               <a:rPr lang="en-US" smtClean="0"/>
-              <a:t>7/1/2026</a:t>
+              <a:t>7/6/2026</a:t>
             </a:fld>
             <a:endParaRPr lang="en-US"/>
           </a:p>
@@ -2969,13 +2970,13 @@
     <p:sldLayoutId id="2147483658" r:id="rId10"/>
     <p:sldLayoutId id="2147483659" r:id="rId11"/>
   </p:sldLayoutIdLst>
-  <mc:AlternateContent xmlns:mc="http://schemas.openxmlformats.org/markup-compatibility/2006">
-    <mc:Choice xmlns:p14="http://schemas.microsoft.com/office/powerpoint/2010/main" Requires="p14">
+  <mc:AlternateContent xmlns:mc="http://schemas.openxmlformats.org/markup-compatibility/2006" xmlns:p14="http://schemas.microsoft.com/office/powerpoint/2010/main">
+    <mc:Choice Requires="p14">
       <p:transition spd="med" p14:dur="700">
         <p:fade/>
       </p:transition>
     </mc:Choice>
-    <mc:Fallback>
+    <mc:Fallback xmlns="">
       <p:transition spd="med">
         <p:fade/>
       </p:transition>
@@ -3407,13 +3408,13 @@
   <p:clrMapOvr>
     <a:masterClrMapping/>
   </p:clrMapOvr>
-  <mc:AlternateContent xmlns:mc="http://schemas.openxmlformats.org/markup-compatibility/2006">
-    <mc:Choice xmlns:p14="http://schemas.microsoft.com/office/powerpoint/2010/main" Requires="p14">
+  <mc:AlternateContent xmlns:mc="http://schemas.openxmlformats.org/markup-compatibility/2006" xmlns:p14="http://schemas.microsoft.com/office/powerpoint/2010/main">
+    <mc:Choice Requires="p14">
       <p:transition spd="med" p14:dur="700">
         <p:fade/>
       </p:transition>
     </mc:Choice>
-    <mc:Fallback>
+    <mc:Fallback xmlns="">
       <p:transition spd="med">
         <p:fade/>
       </p:transition>
@@ -3521,7 +3522,7 @@
         <p:spPr>
           <a:xfrm>
             <a:off x="822960" y="1737360"/>
-            <a:ext cx="7315200" cy="3200400"/>
+            <a:ext cx="3821752" cy="1754326"/>
           </a:xfrm>
           <a:prstGeom prst="rect">
             <a:avLst/>
@@ -3535,6 +3536,8 @@
           <a:lstStyle/>
           <a:p>
             <a:pPr>
+              <a:buFont typeface="Arial" pitchFamily="34" charset="0"/>
+              <a:buChar char="•"/>
               <a:defRPr sz="1800">
                 <a:solidFill>
                   <a:srgbClr val="5A5A5A"/>
@@ -3542,12 +3545,26 @@
               </a:defRPr>
             </a:pPr>
             <a:r>
+              <a:rPr lang="en-US" dirty="0" smtClean="0"/>
+              <a:t> </a:t>
+            </a:r>
+            <a:r>
+              <a:rPr lang="en-US" dirty="0" smtClean="0"/>
+              <a:t> </a:t>
+            </a:r>
+            <a:r>
+              <a:rPr dirty="0" smtClean="0"/>
+              <a:t>Regional </a:t>
+            </a:r>
+            <a:r>
               <a:rPr dirty="0"/>
-              <a:t>• Regional Sales Analysis</a:t>
+              <a:t>Sales Analysis</a:t>
             </a:r>
           </a:p>
           <a:p>
             <a:pPr>
+              <a:buFont typeface="Arial" pitchFamily="34" charset="0"/>
+              <a:buChar char="•"/>
               <a:defRPr sz="1800">
                 <a:solidFill>
                   <a:srgbClr val="5A5A5A"/>
@@ -3555,12 +3572,26 @@
               </a:defRPr>
             </a:pPr>
             <a:r>
+              <a:rPr lang="en-US" dirty="0" smtClean="0"/>
+              <a:t> </a:t>
+            </a:r>
+            <a:r>
+              <a:rPr lang="en-US" dirty="0" smtClean="0"/>
+              <a:t> </a:t>
+            </a:r>
+            <a:r>
+              <a:rPr dirty="0" smtClean="0"/>
+              <a:t>Monthly </a:t>
+            </a:r>
+            <a:r>
               <a:rPr dirty="0"/>
-              <a:t>• Monthly Revenue Trends</a:t>
+              <a:t>Revenue Trends</a:t>
             </a:r>
           </a:p>
           <a:p>
             <a:pPr>
+              <a:buFont typeface="Arial" pitchFamily="34" charset="0"/>
+              <a:buChar char="•"/>
               <a:defRPr sz="1800">
                 <a:solidFill>
                   <a:srgbClr val="5A5A5A"/>
@@ -3568,12 +3599,26 @@
               </a:defRPr>
             </a:pPr>
             <a:r>
+              <a:rPr lang="en-US" dirty="0" smtClean="0"/>
+              <a:t> </a:t>
+            </a:r>
+            <a:r>
+              <a:rPr lang="en-US" dirty="0" smtClean="0"/>
+              <a:t> </a:t>
+            </a:r>
+            <a:r>
+              <a:rPr dirty="0" smtClean="0"/>
+              <a:t>Category </a:t>
+            </a:r>
+            <a:r>
               <a:rPr dirty="0"/>
-              <a:t>• Category Profitability Analysis</a:t>
+              <a:t>Profitability Analysis</a:t>
             </a:r>
           </a:p>
           <a:p>
             <a:pPr>
+              <a:buFont typeface="Arial" pitchFamily="34" charset="0"/>
+              <a:buChar char="•"/>
               <a:defRPr sz="1800">
                 <a:solidFill>
                   <a:srgbClr val="5A5A5A"/>
@@ -3581,8 +3626,106 @@
               </a:defRPr>
             </a:pPr>
             <a:r>
+              <a:rPr lang="en-US" dirty="0" smtClean="0"/>
+              <a:t> </a:t>
+            </a:r>
+            <a:r>
+              <a:rPr lang="en-US" dirty="0" smtClean="0"/>
+              <a:t> </a:t>
+            </a:r>
+            <a:r>
+              <a:rPr dirty="0" smtClean="0"/>
+              <a:t>Product </a:t>
+            </a:r>
+            <a:r>
               <a:rPr dirty="0"/>
-              <a:t>• Product Performance Analysis</a:t>
+              <a:t>Performance Analysis</a:t>
+            </a:r>
+          </a:p>
+          <a:p>
+            <a:pPr>
+              <a:buFont typeface="Arial" pitchFamily="34" charset="0"/>
+              <a:buChar char="•"/>
+              <a:defRPr sz="1800">
+                <a:solidFill>
+                  <a:srgbClr val="5A5A5A"/>
+                </a:solidFill>
+              </a:defRPr>
+            </a:pPr>
+            <a:r>
+              <a:rPr lang="en-US" dirty="0" smtClean="0">
+                <a:solidFill>
+                  <a:srgbClr val="5A5A5A"/>
+                </a:solidFill>
+              </a:rPr>
+              <a:t> </a:t>
+            </a:r>
+            <a:r>
+              <a:rPr lang="en-US" dirty="0" smtClean="0">
+                <a:solidFill>
+                  <a:srgbClr val="5A5A5A"/>
+                </a:solidFill>
+              </a:rPr>
+              <a:t> </a:t>
+            </a:r>
+            <a:r>
+              <a:rPr dirty="0" smtClean="0">
+                <a:solidFill>
+                  <a:srgbClr val="5A5A5A"/>
+                </a:solidFill>
+              </a:rPr>
+              <a:t>Forecast </a:t>
+            </a:r>
+            <a:r>
+              <a:rPr dirty="0">
+                <a:solidFill>
+                  <a:srgbClr val="5A5A5A"/>
+                </a:solidFill>
+              </a:rPr>
+              <a:t>Analysis</a:t>
+            </a:r>
+          </a:p>
+          <a:p>
+            <a:pPr>
+              <a:buFont typeface="Arial" pitchFamily="34" charset="0"/>
+              <a:buChar char="•"/>
+              <a:defRPr sz="1800">
+                <a:solidFill>
+                  <a:srgbClr val="5A5A5A"/>
+                </a:solidFill>
+              </a:defRPr>
+            </a:pPr>
+            <a:r>
+              <a:rPr lang="en-US" dirty="0" smtClean="0">
+                <a:solidFill>
+                  <a:srgbClr val="5A5A5A"/>
+                </a:solidFill>
+              </a:rPr>
+              <a:t> </a:t>
+            </a:r>
+            <a:r>
+              <a:rPr lang="en-US" dirty="0" smtClean="0">
+                <a:solidFill>
+                  <a:srgbClr val="5A5A5A"/>
+                </a:solidFill>
+              </a:rPr>
+              <a:t> </a:t>
+            </a:r>
+            <a:r>
+              <a:rPr dirty="0" smtClean="0">
+                <a:solidFill>
+                  <a:srgbClr val="5A5A5A"/>
+                </a:solidFill>
+              </a:rPr>
+              <a:t>Pareto </a:t>
+            </a:r>
+            <a:r>
+              <a:rPr dirty="0">
+                <a:solidFill>
+                  <a:srgbClr val="5A5A5A"/>
+                </a:solidFill>
+              </a:rPr>
+              <a:t>Product Contribution Analysis</a:t>
             </a:r>
           </a:p>
         </p:txBody>
@@ -3659,13 +3802,13 @@
   <p:clrMapOvr>
     <a:masterClrMapping/>
   </p:clrMapOvr>
-  <mc:AlternateContent xmlns:mc="http://schemas.openxmlformats.org/markup-compatibility/2006">
-    <mc:Choice xmlns:p14="http://schemas.microsoft.com/office/powerpoint/2010/main" Requires="p14">
+  <mc:AlternateContent xmlns:mc="http://schemas.openxmlformats.org/markup-compatibility/2006" xmlns:p14="http://schemas.microsoft.com/office/powerpoint/2010/main">
+    <mc:Choice Requires="p14">
       <p:transition spd="med" p14:dur="700">
         <p:fade/>
       </p:transition>
     </mc:Choice>
-    <mc:Fallback>
+    <mc:Fallback xmlns="">
       <p:transition spd="med">
         <p:fade/>
       </p:transition>
@@ -3986,7 +4129,7 @@
         <p:spPr>
           <a:xfrm>
             <a:off x="822960" y="1737360"/>
-            <a:ext cx="7315200" cy="3200400"/>
+            <a:ext cx="3320524" cy="1754326"/>
           </a:xfrm>
           <a:prstGeom prst="rect">
             <a:avLst/>
@@ -3999,7 +4142,9 @@
           </a:bodyPr>
           <a:lstStyle/>
           <a:p>
-            <a:pPr>
+            <a:pPr marL="92075" indent="-92075">
+              <a:buFont typeface="Arial" pitchFamily="34" charset="0"/>
+              <a:buChar char="•"/>
               <a:defRPr sz="1800">
                 <a:solidFill>
                   <a:srgbClr val="5A5A5A"/>
@@ -4007,12 +4152,26 @@
               </a:defRPr>
             </a:pPr>
             <a:r>
-              <a:rPr dirty="0"/>
-              <a:t>• Regional Sales Dashboard</a:t>
+              <a:rPr lang="en-US" dirty="0" smtClean="0"/>
+              <a:t> </a:t>
+            </a:r>
+            <a:r>
+              <a:rPr lang="en-US" dirty="0" smtClean="0"/>
+              <a:t> </a:t>
+            </a:r>
+            <a:r>
+              <a:rPr dirty="0" smtClean="0"/>
+              <a:t>Regional </a:t>
+            </a:r>
+            <a:r>
+              <a:rPr dirty="0" smtClean="0"/>
+              <a:t>Sales Dashboard</a:t>
             </a:r>
           </a:p>
           <a:p>
             <a:pPr>
+              <a:buFont typeface="Arial" pitchFamily="34" charset="0"/>
+              <a:buChar char="•"/>
               <a:defRPr sz="1800">
                 <a:solidFill>
                   <a:srgbClr val="5A5A5A"/>
@@ -4020,12 +4179,26 @@
               </a:defRPr>
             </a:pPr>
             <a:r>
-              <a:rPr dirty="0"/>
-              <a:t>• Monthly Sales Trends</a:t>
+              <a:rPr lang="en-US" dirty="0" smtClean="0"/>
+              <a:t> </a:t>
+            </a:r>
+            <a:r>
+              <a:rPr lang="en-US" dirty="0" smtClean="0"/>
+              <a:t> </a:t>
+            </a:r>
+            <a:r>
+              <a:rPr dirty="0" smtClean="0"/>
+              <a:t>Monthly </a:t>
+            </a:r>
+            <a:r>
+              <a:rPr dirty="0" smtClean="0"/>
+              <a:t>Sales Trends</a:t>
             </a:r>
           </a:p>
           <a:p>
             <a:pPr>
+              <a:buFont typeface="Arial" pitchFamily="34" charset="0"/>
+              <a:buChar char="•"/>
               <a:defRPr sz="1800">
                 <a:solidFill>
                   <a:srgbClr val="5A5A5A"/>
@@ -4033,12 +4206,26 @@
               </a:defRPr>
             </a:pPr>
             <a:r>
-              <a:rPr dirty="0"/>
-              <a:t>• Category Profitability Reporting</a:t>
+              <a:rPr lang="en-US" dirty="0" smtClean="0"/>
+              <a:t> </a:t>
+            </a:r>
+            <a:r>
+              <a:rPr lang="en-US" dirty="0" smtClean="0"/>
+              <a:t> </a:t>
+            </a:r>
+            <a:r>
+              <a:rPr dirty="0" smtClean="0"/>
+              <a:t>Category </a:t>
+            </a:r>
+            <a:r>
+              <a:rPr dirty="0" smtClean="0"/>
+              <a:t>Profitability Reporting</a:t>
             </a:r>
           </a:p>
           <a:p>
             <a:pPr>
+              <a:buFont typeface="Arial" pitchFamily="34" charset="0"/>
+              <a:buChar char="•"/>
               <a:defRPr sz="1800">
                 <a:solidFill>
                   <a:srgbClr val="5A5A5A"/>
@@ -4046,9 +4233,102 @@
               </a:defRPr>
             </a:pPr>
             <a:r>
-              <a:rPr dirty="0"/>
-              <a:t>• KPI Visualization</a:t>
-            </a:r>
+              <a:rPr lang="en-US" dirty="0" smtClean="0"/>
+              <a:t> </a:t>
+            </a:r>
+            <a:r>
+              <a:rPr lang="en-US" dirty="0" smtClean="0"/>
+              <a:t> </a:t>
+            </a:r>
+            <a:r>
+              <a:rPr dirty="0" smtClean="0"/>
+              <a:t>KPI </a:t>
+            </a:r>
+            <a:r>
+              <a:rPr dirty="0" smtClean="0"/>
+              <a:t>Visualization</a:t>
+            </a:r>
+          </a:p>
+          <a:p>
+            <a:pPr>
+              <a:buFont typeface="Arial" pitchFamily="34" charset="0"/>
+              <a:buChar char="•"/>
+            </a:pPr>
+            <a:r>
+              <a:rPr lang="en-US" dirty="0" smtClean="0">
+                <a:solidFill>
+                  <a:srgbClr val="5A5A5A"/>
+                </a:solidFill>
+              </a:rPr>
+              <a:t> </a:t>
+            </a:r>
+            <a:r>
+              <a:rPr lang="en-US" dirty="0" smtClean="0">
+                <a:solidFill>
+                  <a:srgbClr val="5A5A5A"/>
+                </a:solidFill>
+              </a:rPr>
+              <a:t> </a:t>
+            </a:r>
+            <a:r>
+              <a:rPr dirty="0" smtClean="0">
+                <a:solidFill>
+                  <a:srgbClr val="5A5A5A"/>
+                </a:solidFill>
+              </a:rPr>
+              <a:t>Forecast </a:t>
+            </a:r>
+            <a:r>
+              <a:rPr dirty="0" smtClean="0">
+                <a:solidFill>
+                  <a:srgbClr val="5A5A5A"/>
+                </a:solidFill>
+              </a:rPr>
+              <a:t>Trend Visualization</a:t>
+            </a:r>
+          </a:p>
+          <a:p>
+            <a:pPr>
+              <a:buFont typeface="Arial" pitchFamily="34" charset="0"/>
+              <a:buChar char="•"/>
+            </a:pPr>
+            <a:r>
+              <a:rPr lang="en-US" dirty="0" smtClean="0">
+                <a:solidFill>
+                  <a:srgbClr val="5A5A5A"/>
+                </a:solidFill>
+              </a:rPr>
+              <a:t> </a:t>
+            </a:r>
+            <a:r>
+              <a:rPr lang="en-US" dirty="0" smtClean="0">
+                <a:solidFill>
+                  <a:srgbClr val="5A5A5A"/>
+                </a:solidFill>
+              </a:rPr>
+              <a:t> </a:t>
+            </a:r>
+            <a:r>
+              <a:rPr dirty="0" smtClean="0">
+                <a:solidFill>
+                  <a:srgbClr val="5A5A5A"/>
+                </a:solidFill>
+              </a:rPr>
+              <a:t>Product </a:t>
+            </a:r>
+            <a:r>
+              <a:rPr dirty="0" smtClean="0">
+                <a:solidFill>
+                  <a:srgbClr val="5A5A5A"/>
+                </a:solidFill>
+              </a:rPr>
+              <a:t>Contribution Analysis</a:t>
+            </a:r>
+            <a:endParaRPr dirty="0">
+              <a:solidFill>
+                <a:srgbClr val="5A5A5A"/>
+              </a:solidFill>
+            </a:endParaRPr>
           </a:p>
         </p:txBody>
       </p:sp>
@@ -4124,13 +4404,13 @@
   <p:clrMapOvr>
     <a:masterClrMapping/>
   </p:clrMapOvr>
-  <mc:AlternateContent xmlns:mc="http://schemas.openxmlformats.org/markup-compatibility/2006">
-    <mc:Choice xmlns:p14="http://schemas.microsoft.com/office/powerpoint/2010/main" Requires="p14">
+  <mc:AlternateContent xmlns:mc="http://schemas.openxmlformats.org/markup-compatibility/2006" xmlns:p14="http://schemas.microsoft.com/office/powerpoint/2010/main">
+    <mc:Choice Requires="p14">
       <p:transition spd="med" p14:dur="700">
         <p:fade/>
       </p:transition>
     </mc:Choice>
-    <mc:Fallback>
+    <mc:Fallback xmlns="">
       <p:transition spd="med">
         <p:fade/>
       </p:transition>
@@ -4378,6 +4658,341 @@
       </p:grpSpPr>
       <p:sp>
         <p:nvSpPr>
+          <p:cNvPr id="2" name="Title 1"/>
+          <p:cNvSpPr>
+            <a:spLocks noGrp="1"/>
+          </p:cNvSpPr>
+          <p:nvPr>
+            <p:ph type="title"/>
+          </p:nvPr>
+        </p:nvSpPr>
+        <p:spPr/>
+        <p:txBody>
+          <a:bodyPr>
+            <a:normAutofit/>
+          </a:bodyPr>
+          <a:lstStyle/>
+          <a:p>
+            <a:pPr algn="l"/>
+            <a:r>
+              <a:rPr sz="2400" b="1" dirty="0">
+                <a:solidFill>
+                  <a:srgbClr val="1F4E79"/>
+                </a:solidFill>
+                <a:latin typeface="+mn-lt"/>
+                <a:ea typeface="+mn-ea"/>
+                <a:cs typeface="+mn-cs"/>
+              </a:rPr>
+              <a:t>Dashboard &amp; Analytics Visualizations</a:t>
+            </a:r>
+          </a:p>
+        </p:txBody>
+      </p:sp>
+      <p:sp>
+        <p:nvSpPr>
+          <p:cNvPr id="3" name="Content Placeholder 2"/>
+          <p:cNvSpPr>
+            <a:spLocks noGrp="1"/>
+          </p:cNvSpPr>
+          <p:nvPr>
+            <p:ph idx="1"/>
+          </p:nvPr>
+        </p:nvSpPr>
+        <p:spPr/>
+        <p:txBody>
+          <a:bodyPr>
+            <a:normAutofit/>
+          </a:bodyPr>
+          <a:lstStyle/>
+          <a:p>
+            <a:pPr marL="0" indent="0"/>
+            <a:r>
+              <a:rPr lang="en-US" sz="1800" dirty="0" smtClean="0">
+                <a:solidFill>
+                  <a:srgbClr val="5A5A5A"/>
+                </a:solidFill>
+              </a:rPr>
+              <a:t> </a:t>
+            </a:r>
+            <a:r>
+              <a:rPr sz="1800" dirty="0" smtClean="0">
+                <a:solidFill>
+                  <a:srgbClr val="5A5A5A"/>
+                </a:solidFill>
+              </a:rPr>
+              <a:t>Tableau KPI Dashboard</a:t>
+            </a:r>
+            <a:r>
+              <a:rPr lang="en-US" sz="1800" dirty="0" smtClean="0">
+                <a:solidFill>
+                  <a:srgbClr val="5A5A5A"/>
+                </a:solidFill>
+              </a:rPr>
+              <a:t> </a:t>
+            </a:r>
+          </a:p>
+          <a:p>
+            <a:pPr marL="0" indent="0">
+              <a:tabLst>
+                <a:tab pos="0" algn="l"/>
+              </a:tabLst>
+            </a:pPr>
+            <a:r>
+              <a:rPr lang="en-US" sz="1800" dirty="0" smtClean="0">
+                <a:solidFill>
+                  <a:srgbClr val="5A5A5A"/>
+                </a:solidFill>
+              </a:rPr>
+              <a:t> </a:t>
+            </a:r>
+            <a:r>
+              <a:rPr sz="1800" dirty="0" smtClean="0">
+                <a:solidFill>
+                  <a:srgbClr val="5A5A5A"/>
+                </a:solidFill>
+              </a:rPr>
+              <a:t>Sales </a:t>
+            </a:r>
+            <a:r>
+              <a:rPr sz="1800" dirty="0">
+                <a:solidFill>
+                  <a:srgbClr val="5A5A5A"/>
+                </a:solidFill>
+              </a:rPr>
+              <a:t>Forecast Analysis</a:t>
+            </a:r>
+          </a:p>
+          <a:p>
+            <a:pPr marL="0" indent="0"/>
+            <a:r>
+              <a:rPr lang="en-US" sz="1800" dirty="0" smtClean="0">
+                <a:solidFill>
+                  <a:srgbClr val="5A5A5A"/>
+                </a:solidFill>
+              </a:rPr>
+              <a:t> </a:t>
+            </a:r>
+            <a:r>
+              <a:rPr sz="1800" dirty="0" smtClean="0">
+                <a:solidFill>
+                  <a:srgbClr val="5A5A5A"/>
+                </a:solidFill>
+              </a:rPr>
+              <a:t>Pareto </a:t>
+            </a:r>
+            <a:r>
+              <a:rPr sz="1800" dirty="0">
+                <a:solidFill>
+                  <a:srgbClr val="5A5A5A"/>
+                </a:solidFill>
+              </a:rPr>
+              <a:t>Product Contribution Analysis</a:t>
+            </a:r>
+          </a:p>
+          <a:p>
+            <a:pPr marL="0" indent="0"/>
+            <a:r>
+              <a:rPr lang="en-US" sz="1800" dirty="0" smtClean="0">
+                <a:solidFill>
+                  <a:srgbClr val="5A5A5A"/>
+                </a:solidFill>
+              </a:rPr>
+              <a:t> </a:t>
+            </a:r>
+            <a:r>
+              <a:rPr sz="1800" dirty="0" smtClean="0">
+                <a:solidFill>
+                  <a:srgbClr val="5A5A5A"/>
+                </a:solidFill>
+              </a:rPr>
+              <a:t>Regional </a:t>
+            </a:r>
+            <a:r>
+              <a:rPr sz="1800" dirty="0">
+                <a:solidFill>
+                  <a:srgbClr val="5A5A5A"/>
+                </a:solidFill>
+              </a:rPr>
+              <a:t>&amp; Category Profitability Insights</a:t>
+            </a:r>
+          </a:p>
+          <a:p>
+            <a:pPr marL="0" indent="0"/>
+            <a:r>
+              <a:rPr lang="en-US" sz="1800" dirty="0" smtClean="0">
+                <a:solidFill>
+                  <a:srgbClr val="5A5A5A"/>
+                </a:solidFill>
+              </a:rPr>
+              <a:t> </a:t>
+            </a:r>
+            <a:r>
+              <a:rPr sz="1800" dirty="0" smtClean="0">
+                <a:solidFill>
+                  <a:srgbClr val="5A5A5A"/>
+                </a:solidFill>
+              </a:rPr>
+              <a:t>Operational </a:t>
+            </a:r>
+            <a:r>
+              <a:rPr sz="1800" dirty="0">
+                <a:solidFill>
+                  <a:srgbClr val="5A5A5A"/>
+                </a:solidFill>
+              </a:rPr>
+              <a:t>KPI Reporting Visualizations</a:t>
+            </a:r>
+          </a:p>
+        </p:txBody>
+      </p:sp>
+      <p:sp>
+        <p:nvSpPr>
+          <p:cNvPr id="4" name="TextBox 3"/>
+          <p:cNvSpPr txBox="1"/>
+          <p:nvPr/>
+        </p:nvSpPr>
+        <p:spPr>
+          <a:xfrm>
+            <a:off x="274320" y="91440"/>
+            <a:ext cx="7315200" cy="274320"/>
+          </a:xfrm>
+          <a:prstGeom prst="rect">
+            <a:avLst/>
+          </a:prstGeom>
+          <a:noFill/>
+        </p:spPr>
+        <p:txBody>
+          <a:bodyPr wrap="none">
+            <a:spAutoFit/>
+          </a:bodyPr>
+          <a:lstStyle/>
+          <a:p>
+            <a:pPr>
+              <a:defRPr sz="1400" b="1"/>
+            </a:pPr>
+            <a:r>
+              <a:rPr>
+                <a:solidFill>
+                  <a:srgbClr val="1F4E79"/>
+                </a:solidFill>
+              </a:rPr>
+              <a:t>Enterprise Sales &amp; Operational Analytics Project</a:t>
+            </a:r>
+          </a:p>
+        </p:txBody>
+      </p:sp>
+      <p:sp>
+        <p:nvSpPr>
+          <p:cNvPr id="5" name="TextBox 4"/>
+          <p:cNvSpPr txBox="1"/>
+          <p:nvPr/>
+        </p:nvSpPr>
+        <p:spPr>
+          <a:xfrm>
+            <a:off x="274320" y="6309360"/>
+            <a:ext cx="4572000" cy="274320"/>
+          </a:xfrm>
+          <a:prstGeom prst="rect">
+            <a:avLst/>
+          </a:prstGeom>
+          <a:noFill/>
+        </p:spPr>
+        <p:txBody>
+          <a:bodyPr wrap="none">
+            <a:spAutoFit/>
+          </a:bodyPr>
+          <a:lstStyle/>
+          <a:p>
+            <a:pPr>
+              <a:defRPr sz="1000"/>
+            </a:pPr>
+            <a:r>
+              <a:rPr sz="1000">
+                <a:solidFill>
+                  <a:srgbClr val="595959"/>
+                </a:solidFill>
+              </a:rPr>
+              <a:t>Confidential • For Internal &amp; Portfolio Use</a:t>
+            </a:r>
+          </a:p>
+        </p:txBody>
+      </p:sp>
+      <p:sp>
+        <p:nvSpPr>
+          <p:cNvPr id="6" name="TextBox 5"/>
+          <p:cNvSpPr txBox="1"/>
+          <p:nvPr/>
+        </p:nvSpPr>
+        <p:spPr>
+          <a:xfrm>
+            <a:off x="8229600" y="6309360"/>
+            <a:ext cx="316112" cy="246221"/>
+          </a:xfrm>
+          <a:prstGeom prst="rect">
+            <a:avLst/>
+          </a:prstGeom>
+          <a:noFill/>
+        </p:spPr>
+        <p:txBody>
+          <a:bodyPr wrap="none">
+            <a:spAutoFit/>
+          </a:bodyPr>
+          <a:lstStyle/>
+          <a:p>
+            <a:pPr>
+              <a:defRPr sz="1000" b="1"/>
+            </a:pPr>
+            <a:r>
+              <a:rPr b="1" dirty="0" smtClean="0">
+                <a:solidFill>
+                  <a:srgbClr val="808080"/>
+                </a:solidFill>
+              </a:rPr>
+              <a:t>1</a:t>
+            </a:r>
+            <a:r>
+              <a:rPr lang="en-US" b="1" dirty="0" smtClean="0">
+                <a:solidFill>
+                  <a:srgbClr val="808080"/>
+                </a:solidFill>
+              </a:rPr>
+              <a:t>2</a:t>
+            </a:r>
+            <a:endParaRPr b="1" dirty="0">
+              <a:solidFill>
+                <a:srgbClr val="808080"/>
+              </a:solidFill>
+            </a:endParaRPr>
+          </a:p>
+        </p:txBody>
+      </p:sp>
+    </p:spTree>
+  </p:cSld>
+  <p:clrMapOvr>
+    <a:masterClrMapping/>
+  </p:clrMapOvr>
+</p:sld>
+</file>
+
+<file path=ppt/slides/slide13.xml><?xml version="1.0" encoding="utf-8"?>
+<p:sld xmlns:a="http://schemas.openxmlformats.org/drawingml/2006/main" xmlns:r="http://schemas.openxmlformats.org/officeDocument/2006/relationships" xmlns:p="http://schemas.openxmlformats.org/presentationml/2006/main">
+  <p:cSld>
+    <p:spTree>
+      <p:nvGrpSpPr>
+        <p:cNvPr id="1" name=""/>
+        <p:cNvGrpSpPr/>
+        <p:nvPr/>
+      </p:nvGrpSpPr>
+      <p:grpSpPr>
+        <a:xfrm>
+          <a:off x="0" y="0"/>
+          <a:ext cx="0" cy="0"/>
+          <a:chOff x="0" y="0"/>
+          <a:chExt cx="0" cy="0"/>
+        </a:xfrm>
+      </p:grpSpPr>
+      <p:sp>
+        <p:nvSpPr>
           <p:cNvPr id="2" name="TextBox 1"/>
           <p:cNvSpPr txBox="1"/>
           <p:nvPr/>
@@ -4451,7 +5066,7 @@
         <p:spPr>
           <a:xfrm>
             <a:off x="822960" y="1737360"/>
-            <a:ext cx="7315200" cy="3200400"/>
+            <a:ext cx="3643946" cy="1200329"/>
           </a:xfrm>
           <a:prstGeom prst="rect">
             <a:avLst/>
@@ -4472,8 +5087,20 @@
               </a:defRPr>
             </a:pPr>
             <a:r>
+              <a:rPr dirty="0" smtClean="0"/>
+              <a:t>•</a:t>
+            </a:r>
+            <a:r>
+              <a:rPr lang="en-US" dirty="0" smtClean="0"/>
+              <a:t> </a:t>
+            </a:r>
+            <a:r>
+              <a:rPr dirty="0" smtClean="0"/>
+              <a:t>Improved </a:t>
+            </a:r>
+            <a:r>
               <a:rPr dirty="0"/>
-              <a:t>• Improved operational visibility</a:t>
+              <a:t>operational visibility</a:t>
             </a:r>
           </a:p>
           <a:p>
@@ -4485,8 +5112,20 @@
               </a:defRPr>
             </a:pPr>
             <a:r>
+              <a:rPr dirty="0" smtClean="0"/>
+              <a:t>•</a:t>
+            </a:r>
+            <a:r>
+              <a:rPr lang="en-US" dirty="0" smtClean="0"/>
+              <a:t> </a:t>
+            </a:r>
+            <a:r>
+              <a:rPr dirty="0" smtClean="0"/>
+              <a:t>Faster </a:t>
+            </a:r>
+            <a:r>
               <a:rPr dirty="0"/>
-              <a:t>• Faster KPI reporting</a:t>
+              <a:t>KPI reporting</a:t>
             </a:r>
           </a:p>
           <a:p>
@@ -4498,8 +5137,20 @@
               </a:defRPr>
             </a:pPr>
             <a:r>
+              <a:rPr dirty="0" smtClean="0"/>
+              <a:t>•</a:t>
+            </a:r>
+            <a:r>
+              <a:rPr lang="en-US" dirty="0" smtClean="0"/>
+              <a:t> </a:t>
+            </a:r>
+            <a:r>
+              <a:rPr dirty="0" smtClean="0"/>
+              <a:t>Better </a:t>
+            </a:r>
+            <a:r>
               <a:rPr dirty="0"/>
-              <a:t>• Better profitability monitoring</a:t>
+              <a:t>profitability monitoring</a:t>
             </a:r>
           </a:p>
           <a:p>
@@ -4511,8 +5162,20 @@
               </a:defRPr>
             </a:pPr>
             <a:r>
+              <a:rPr dirty="0" smtClean="0"/>
+              <a:t>•</a:t>
+            </a:r>
+            <a:r>
+              <a:rPr lang="en-US" dirty="0" smtClean="0"/>
+              <a:t> </a:t>
+            </a:r>
+            <a:r>
+              <a:rPr dirty="0" smtClean="0"/>
+              <a:t>Enhanced </a:t>
+            </a:r>
+            <a:r>
               <a:rPr dirty="0"/>
-              <a:t>• Enhanced decision-making support</a:t>
+              <a:t>decision-making support</a:t>
             </a:r>
           </a:p>
         </p:txBody>
@@ -4558,8 +5221,8 @@
         </p:nvSpPr>
         <p:spPr>
           <a:xfrm>
-            <a:off x="8229600" y="6263640"/>
-            <a:ext cx="274320" cy="274320"/>
+            <a:off x="8187808" y="6263640"/>
+            <a:ext cx="316112" cy="246221"/>
           </a:xfrm>
           <a:prstGeom prst="rect">
             <a:avLst/>
@@ -4574,13 +5237,26 @@
           <a:p>
             <a:pPr algn="r"/>
             <a:r>
-              <a:rPr sz="1000">
-                <a:solidFill>
-                  <a:srgbClr val="5A5A5A"/>
-                </a:solidFill>
-              </a:rPr>
-              <a:t>12</a:t>
-            </a:r>
+              <a:rPr sz="1000" dirty="0" smtClean="0">
+                <a:solidFill>
+                  <a:srgbClr val="5A5A5A"/>
+                </a:solidFill>
+              </a:rPr>
+              <a:t>1</a:t>
+            </a:r>
+            <a:r>
+              <a:rPr lang="en-US" sz="1000" dirty="0" smtClean="0">
+                <a:solidFill>
+                  <a:srgbClr val="5A5A5A"/>
+                </a:solidFill>
+              </a:rPr>
+              <a:t>3</a:t>
+            </a:r>
+            <a:endParaRPr sz="1000" dirty="0">
+              <a:solidFill>
+                <a:srgbClr val="5A5A5A"/>
+              </a:solidFill>
+            </a:endParaRPr>
           </a:p>
         </p:txBody>
       </p:sp>
@@ -4589,13 +5265,13 @@
   <p:clrMapOvr>
     <a:masterClrMapping/>
   </p:clrMapOvr>
-  <mc:AlternateContent xmlns:mc="http://schemas.openxmlformats.org/markup-compatibility/2006">
-    <mc:Choice xmlns:p14="http://schemas.microsoft.com/office/powerpoint/2010/main" Requires="p14">
+  <mc:AlternateContent xmlns:mc="http://schemas.openxmlformats.org/markup-compatibility/2006" xmlns:p14="http://schemas.microsoft.com/office/powerpoint/2010/main">
+    <mc:Choice Requires="p14">
       <p:transition spd="med" p14:dur="700">
         <p:fade/>
       </p:transition>
     </mc:Choice>
-    <mc:Fallback>
+    <mc:Fallback xmlns="">
       <p:transition spd="med">
         <p:fade/>
       </p:transition>
@@ -4824,7 +5500,7 @@
 </p:sld>
 </file>
 
-<file path=ppt/slides/slide13.xml><?xml version="1.0" encoding="utf-8"?>
+<file path=ppt/slides/slide14.xml><?xml version="1.0" encoding="utf-8"?>
 <p:sld xmlns:a="http://schemas.openxmlformats.org/drawingml/2006/main" xmlns:r="http://schemas.openxmlformats.org/officeDocument/2006/relationships" xmlns:p="http://schemas.openxmlformats.org/presentationml/2006/main">
   <p:cSld>
     <p:spTree>
@@ -4897,7 +5573,7 @@
           <a:lstStyle/>
           <a:p>
             <a:r>
-              <a:rPr sz="2400" b="1">
+              <a:rPr sz="2400" b="1" dirty="0">
                 <a:solidFill>
                   <a:srgbClr val="003366"/>
                 </a:solidFill>
@@ -4916,7 +5592,7 @@
         <p:spPr>
           <a:xfrm>
             <a:off x="822960" y="1737360"/>
-            <a:ext cx="7315200" cy="3200400"/>
+            <a:ext cx="6808595" cy="1200329"/>
           </a:xfrm>
           <a:prstGeom prst="rect">
             <a:avLst/>
@@ -4929,42 +5605,136 @@
           </a:bodyPr>
           <a:lstStyle/>
           <a:p>
-            <a:pPr>
-              <a:defRPr sz="1800">
-                <a:solidFill>
-                  <a:srgbClr val="5A5A5A"/>
-                </a:solidFill>
-              </a:defRPr>
-            </a:pPr>
-            <a:r>
-              <a:rPr dirty="0"/>
-              <a:t>• Successful enterprise analytics workflow implementation</a:t>
-            </a:r>
-          </a:p>
-          <a:p>
-            <a:pPr>
-              <a:defRPr sz="1800">
-                <a:solidFill>
-                  <a:srgbClr val="5A5A5A"/>
-                </a:solidFill>
-              </a:defRPr>
-            </a:pPr>
-            <a:r>
-              <a:rPr dirty="0"/>
-              <a:t>• Improved KPI visibility and reporting</a:t>
-            </a:r>
-          </a:p>
-          <a:p>
-            <a:pPr>
-              <a:defRPr sz="1800">
-                <a:solidFill>
-                  <a:srgbClr val="5A5A5A"/>
-                </a:solidFill>
-              </a:defRPr>
-            </a:pPr>
-            <a:r>
-              <a:rPr dirty="0"/>
-              <a:t>• Future ETL automation and predictive analytics enhancements</a:t>
+            <a:r>
+              <a:rPr dirty="0" smtClean="0">
+                <a:solidFill>
+                  <a:srgbClr val="5A5A5A"/>
+                </a:solidFill>
+              </a:rPr>
+              <a:t>•</a:t>
+            </a:r>
+            <a:r>
+              <a:rPr lang="en-US" dirty="0" smtClean="0">
+                <a:solidFill>
+                  <a:srgbClr val="5A5A5A"/>
+                </a:solidFill>
+              </a:rPr>
+              <a:t> </a:t>
+            </a:r>
+            <a:r>
+              <a:rPr dirty="0" smtClean="0">
+                <a:solidFill>
+                  <a:srgbClr val="5A5A5A"/>
+                </a:solidFill>
+              </a:rPr>
+              <a:t>Successful </a:t>
+            </a:r>
+            <a:r>
+              <a:rPr dirty="0">
+                <a:solidFill>
+                  <a:srgbClr val="5A5A5A"/>
+                </a:solidFill>
+              </a:rPr>
+              <a:t>enterprise analytics workflow implementation</a:t>
+            </a:r>
+          </a:p>
+          <a:p>
+            <a:r>
+              <a:rPr dirty="0" smtClean="0">
+                <a:solidFill>
+                  <a:srgbClr val="5A5A5A"/>
+                </a:solidFill>
+              </a:rPr>
+              <a:t>•</a:t>
+            </a:r>
+            <a:r>
+              <a:rPr lang="en-US" dirty="0" smtClean="0">
+                <a:solidFill>
+                  <a:srgbClr val="5A5A5A"/>
+                </a:solidFill>
+              </a:rPr>
+              <a:t> </a:t>
+            </a:r>
+            <a:r>
+              <a:rPr dirty="0" smtClean="0">
+                <a:solidFill>
+                  <a:srgbClr val="5A5A5A"/>
+                </a:solidFill>
+              </a:rPr>
+              <a:t>Improved </a:t>
+            </a:r>
+            <a:r>
+              <a:rPr dirty="0">
+                <a:solidFill>
+                  <a:srgbClr val="5A5A5A"/>
+                </a:solidFill>
+              </a:rPr>
+              <a:t>KPI visibility and reporting</a:t>
+            </a:r>
+          </a:p>
+          <a:p>
+            <a:r>
+              <a:rPr smtClean="0">
+                <a:solidFill>
+                  <a:srgbClr val="5A5A5A"/>
+                </a:solidFill>
+              </a:rPr>
+              <a:t>•</a:t>
+            </a:r>
+            <a:r>
+              <a:rPr lang="en-US" smtClean="0">
+                <a:solidFill>
+                  <a:srgbClr val="5A5A5A"/>
+                </a:solidFill>
+              </a:rPr>
+              <a:t> </a:t>
+            </a:r>
+            <a:r>
+              <a:rPr smtClean="0">
+                <a:solidFill>
+                  <a:srgbClr val="5A5A5A"/>
+                </a:solidFill>
+              </a:rPr>
+              <a:t>Future </a:t>
+            </a:r>
+            <a:r>
+              <a:rPr dirty="0">
+                <a:solidFill>
+                  <a:srgbClr val="5A5A5A"/>
+                </a:solidFill>
+              </a:rPr>
+              <a:t>enhancements include ETL automation, Power BI integration, </a:t>
+            </a:r>
+            <a:endParaRPr lang="en-US" dirty="0" smtClean="0">
+              <a:solidFill>
+                <a:srgbClr val="5A5A5A"/>
+              </a:solidFill>
+            </a:endParaRPr>
+          </a:p>
+          <a:p>
+            <a:r>
+              <a:rPr lang="en-US" dirty="0" smtClean="0">
+                <a:solidFill>
+                  <a:srgbClr val="5A5A5A"/>
+                </a:solidFill>
+              </a:rPr>
+              <a:t>   </a:t>
+            </a:r>
+            <a:r>
+              <a:rPr dirty="0" smtClean="0">
+                <a:solidFill>
+                  <a:srgbClr val="5A5A5A"/>
+                </a:solidFill>
+              </a:rPr>
+              <a:t>and </a:t>
+            </a:r>
+            <a:r>
+              <a:rPr dirty="0">
+                <a:solidFill>
+                  <a:srgbClr val="5A5A5A"/>
+                </a:solidFill>
+              </a:rPr>
+              <a:t>advanced forecasting analytics.</a:t>
             </a:r>
           </a:p>
         </p:txBody>
@@ -5010,8 +5780,8 @@
         </p:nvSpPr>
         <p:spPr>
           <a:xfrm>
-            <a:off x="8229600" y="6263640"/>
-            <a:ext cx="274320" cy="274320"/>
+            <a:off x="8187808" y="6263640"/>
+            <a:ext cx="316112" cy="246221"/>
           </a:xfrm>
           <a:prstGeom prst="rect">
             <a:avLst/>
@@ -5026,13 +5796,26 @@
           <a:p>
             <a:pPr algn="r"/>
             <a:r>
-              <a:rPr sz="1000">
-                <a:solidFill>
-                  <a:srgbClr val="5A5A5A"/>
-                </a:solidFill>
-              </a:rPr>
-              <a:t>13</a:t>
-            </a:r>
+              <a:rPr sz="1000" dirty="0" smtClean="0">
+                <a:solidFill>
+                  <a:srgbClr val="5A5A5A"/>
+                </a:solidFill>
+              </a:rPr>
+              <a:t>1</a:t>
+            </a:r>
+            <a:r>
+              <a:rPr lang="en-US" sz="1000" dirty="0" smtClean="0">
+                <a:solidFill>
+                  <a:srgbClr val="5A5A5A"/>
+                </a:solidFill>
+              </a:rPr>
+              <a:t>4</a:t>
+            </a:r>
+            <a:endParaRPr sz="1000" dirty="0">
+              <a:solidFill>
+                <a:srgbClr val="5A5A5A"/>
+              </a:solidFill>
+            </a:endParaRPr>
           </a:p>
         </p:txBody>
       </p:sp>
@@ -5041,13 +5824,13 @@
   <p:clrMapOvr>
     <a:masterClrMapping/>
   </p:clrMapOvr>
-  <mc:AlternateContent xmlns:mc="http://schemas.openxmlformats.org/markup-compatibility/2006">
-    <mc:Choice xmlns:p14="http://schemas.microsoft.com/office/powerpoint/2010/main" Requires="p14">
+  <mc:AlternateContent xmlns:mc="http://schemas.openxmlformats.org/markup-compatibility/2006" xmlns:p14="http://schemas.microsoft.com/office/powerpoint/2010/main">
+    <mc:Choice Requires="p14">
       <p:transition spd="med" p14:dur="700">
         <p:fade/>
       </p:transition>
     </mc:Choice>
-    <mc:Fallback>
+    <mc:Fallback xmlns="">
       <p:transition spd="med">
         <p:fade/>
       </p:transition>
@@ -5202,6 +5985,49 @@
                                   </p:childTnLst>
                                 </p:cTn>
                               </p:par>
+                              <p:par>
+                                <p:cTn id="14" presetID="10" presetClass="entr" presetSubtype="0" fill="hold" nodeType="withEffect">
+                                  <p:stCondLst>
+                                    <p:cond delay="0"/>
+                                  </p:stCondLst>
+                                  <p:childTnLst>
+                                    <p:set>
+                                      <p:cBhvr>
+                                        <p:cTn id="15" dur="1" fill="hold">
+                                          <p:stCondLst>
+                                            <p:cond delay="0"/>
+                                          </p:stCondLst>
+                                        </p:cTn>
+                                        <p:tgtEl>
+                                          <p:spTgt spid="4">
+                                            <p:txEl>
+                                              <p:pRg st="3" end="3"/>
+                                            </p:txEl>
+                                          </p:spTgt>
+                                        </p:tgtEl>
+                                        <p:attrNameLst>
+                                          <p:attrName>style.visibility</p:attrName>
+                                        </p:attrNameLst>
+                                      </p:cBhvr>
+                                      <p:to>
+                                        <p:strVal val="visible"/>
+                                      </p:to>
+                                    </p:set>
+                                    <p:animEffect transition="in" filter="fade">
+                                      <p:cBhvr>
+                                        <p:cTn id="16" dur="500"/>
+                                        <p:tgtEl>
+                                          <p:spTgt spid="4">
+                                            <p:txEl>
+                                              <p:pRg st="3" end="3"/>
+                                            </p:txEl>
+                                          </p:spTgt>
+                                        </p:tgtEl>
+                                      </p:cBhvr>
+                                    </p:animEffect>
+                                  </p:childTnLst>
+                                </p:cTn>
+                              </p:par>
                             </p:childTnLst>
                           </p:cTn>
                         </p:par>
@@ -5458,13 +6284,13 @@
   <p:clrMapOvr>
     <a:masterClrMapping/>
   </p:clrMapOvr>
-  <mc:AlternateContent xmlns:mc="http://schemas.openxmlformats.org/markup-compatibility/2006">
-    <mc:Choice xmlns:p14="http://schemas.microsoft.com/office/powerpoint/2010/main" Requires="p14">
+  <mc:AlternateContent xmlns:mc="http://schemas.openxmlformats.org/markup-compatibility/2006" xmlns:p14="http://schemas.microsoft.com/office/powerpoint/2010/main">
+    <mc:Choice Requires="p14">
       <p:transition spd="med" p14:dur="700">
         <p:fade/>
       </p:transition>
     </mc:Choice>
-    <mc:Fallback>
+    <mc:Fallback xmlns="">
       <p:transition spd="med">
         <p:fade/>
       </p:transition>
@@ -5880,13 +6706,13 @@
   <p:clrMapOvr>
     <a:masterClrMapping/>
   </p:clrMapOvr>
-  <mc:AlternateContent xmlns:mc="http://schemas.openxmlformats.org/markup-compatibility/2006">
-    <mc:Choice xmlns:p14="http://schemas.microsoft.com/office/powerpoint/2010/main" Requires="p14">
+  <mc:AlternateContent xmlns:mc="http://schemas.openxmlformats.org/markup-compatibility/2006" xmlns:p14="http://schemas.microsoft.com/office/powerpoint/2010/main">
+    <mc:Choice Requires="p14">
       <p:transition spd="med" p14:dur="700">
         <p:fade/>
       </p:transition>
     </mc:Choice>
-    <mc:Fallback>
+    <mc:Fallback xmlns="">
       <p:transition spd="med">
         <p:fade/>
       </p:transition>
@@ -6353,13 +7179,13 @@
   <p:clrMapOvr>
     <a:masterClrMapping/>
   </p:clrMapOvr>
-  <mc:AlternateContent xmlns:mc="http://schemas.openxmlformats.org/markup-compatibility/2006">
-    <mc:Choice xmlns:p14="http://schemas.microsoft.com/office/powerpoint/2010/main" Requires="p14">
+  <mc:AlternateContent xmlns:mc="http://schemas.openxmlformats.org/markup-compatibility/2006" xmlns:p14="http://schemas.microsoft.com/office/powerpoint/2010/main">
+    <mc:Choice Requires="p14">
       <p:transition spd="med" p14:dur="700">
         <p:fade/>
       </p:transition>
     </mc:Choice>
-    <mc:Fallback>
+    <mc:Fallback xmlns="">
       <p:transition spd="med">
         <p:fade/>
       </p:transition>
@@ -6680,7 +7506,7 @@
         <p:spPr>
           <a:xfrm>
             <a:off x="822960" y="1737360"/>
-            <a:ext cx="7315200" cy="3200400"/>
+            <a:ext cx="6809493" cy="1477328"/>
           </a:xfrm>
           <a:prstGeom prst="rect">
             <a:avLst/>
@@ -6693,7 +7519,9 @@
           </a:bodyPr>
           <a:lstStyle/>
           <a:p>
-            <a:pPr>
+            <a:pPr marL="92075" indent="-92075">
+              <a:buFont typeface="Arial" pitchFamily="34" charset="0"/>
+              <a:buChar char="•"/>
               <a:defRPr sz="1800">
                 <a:solidFill>
                   <a:srgbClr val="5A5A5A"/>
@@ -6701,12 +7529,26 @@
               </a:defRPr>
             </a:pPr>
             <a:r>
+              <a:rPr lang="en-US" dirty="0" smtClean="0"/>
+              <a:t> </a:t>
+            </a:r>
+            <a:r>
+              <a:rPr lang="en-US" dirty="0" smtClean="0"/>
+              <a:t> </a:t>
+            </a:r>
+            <a:r>
+              <a:rPr dirty="0" smtClean="0"/>
+              <a:t>Develop </a:t>
+            </a:r>
+            <a:r>
               <a:rPr dirty="0"/>
-              <a:t>• Develop enterprise analytics workflow</a:t>
-            </a:r>
-          </a:p>
-          <a:p>
-            <a:pPr>
+              <a:t>enterprise analytics workflow</a:t>
+            </a:r>
+          </a:p>
+          <a:p>
+            <a:pPr marL="92075" indent="-92075">
+              <a:buFont typeface="Arial" pitchFamily="34" charset="0"/>
+              <a:buChar char="•"/>
               <a:defRPr sz="1800">
                 <a:solidFill>
                   <a:srgbClr val="5A5A5A"/>
@@ -6714,12 +7556,26 @@
               </a:defRPr>
             </a:pPr>
             <a:r>
+              <a:rPr lang="en-US" dirty="0" smtClean="0"/>
+              <a:t> </a:t>
+            </a:r>
+            <a:r>
+              <a:rPr lang="en-US" dirty="0" smtClean="0"/>
+              <a:t> </a:t>
+            </a:r>
+            <a:r>
+              <a:rPr dirty="0" smtClean="0"/>
+              <a:t>Implement </a:t>
+            </a:r>
+            <a:r>
               <a:rPr dirty="0"/>
-              <a:t>• Implement SQL KPI reporting</a:t>
-            </a:r>
-          </a:p>
-          <a:p>
-            <a:pPr>
+              <a:t>SQL KPI reporting</a:t>
+            </a:r>
+          </a:p>
+          <a:p>
+            <a:pPr marL="92075" indent="-92075">
+              <a:buFont typeface="Arial" pitchFamily="34" charset="0"/>
+              <a:buChar char="•"/>
               <a:defRPr sz="1800">
                 <a:solidFill>
                   <a:srgbClr val="5A5A5A"/>
@@ -6727,12 +7583,26 @@
               </a:defRPr>
             </a:pPr>
             <a:r>
+              <a:rPr lang="en-US" dirty="0" smtClean="0"/>
+              <a:t> </a:t>
+            </a:r>
+            <a:r>
+              <a:rPr lang="en-US" dirty="0" smtClean="0"/>
+              <a:t> </a:t>
+            </a:r>
+            <a:r>
+              <a:rPr dirty="0" smtClean="0"/>
+              <a:t>Create </a:t>
+            </a:r>
+            <a:r>
               <a:rPr dirty="0"/>
-              <a:t>• Create Tableau dashboards</a:t>
-            </a:r>
-          </a:p>
-          <a:p>
-            <a:pPr>
+              <a:t>Tableau dashboards</a:t>
+            </a:r>
+          </a:p>
+          <a:p>
+            <a:pPr marL="92075" indent="-92075">
+              <a:buFont typeface="Arial" pitchFamily="34" charset="0"/>
+              <a:buChar char="•"/>
               <a:defRPr sz="1800">
                 <a:solidFill>
                   <a:srgbClr val="5A5A5A"/>
@@ -6740,8 +7610,63 @@
               </a:defRPr>
             </a:pPr>
             <a:r>
+              <a:rPr lang="en-US" dirty="0" smtClean="0"/>
+              <a:t> </a:t>
+            </a:r>
+            <a:r>
+              <a:rPr lang="en-US" dirty="0" smtClean="0"/>
+              <a:t> </a:t>
+            </a:r>
+            <a:r>
+              <a:rPr dirty="0" smtClean="0"/>
+              <a:t>Demonstrate </a:t>
+            </a:r>
+            <a:r>
               <a:rPr dirty="0"/>
-              <a:t>• Demonstrate end-to-end analytics integration</a:t>
+              <a:t>end-to-end analytics integration</a:t>
+            </a:r>
+          </a:p>
+          <a:p>
+            <a:pPr marL="92075" indent="-92075">
+              <a:buFont typeface="Arial" pitchFamily="34" charset="0"/>
+              <a:buChar char="•"/>
+              <a:defRPr sz="1800">
+                <a:solidFill>
+                  <a:srgbClr val="5A5A5A"/>
+                </a:solidFill>
+              </a:defRPr>
+            </a:pPr>
+            <a:r>
+              <a:rPr lang="en-US" dirty="0" smtClean="0">
+                <a:solidFill>
+                  <a:srgbClr val="5A5A5A"/>
+                </a:solidFill>
+              </a:rPr>
+              <a:t> </a:t>
+            </a:r>
+            <a:r>
+              <a:rPr lang="en-US" dirty="0" smtClean="0">
+                <a:solidFill>
+                  <a:srgbClr val="5A5A5A"/>
+                </a:solidFill>
+              </a:rPr>
+              <a:t> </a:t>
+            </a:r>
+            <a:r>
+              <a:rPr dirty="0" smtClean="0">
+                <a:solidFill>
+                  <a:srgbClr val="5A5A5A"/>
+                </a:solidFill>
+              </a:rPr>
+              <a:t>Perform </a:t>
+            </a:r>
+            <a:r>
+              <a:rPr dirty="0">
+                <a:solidFill>
+                  <a:srgbClr val="5A5A5A"/>
+                </a:solidFill>
+              </a:rPr>
+              <a:t>advanced analytics including forecasting and trend analysis</a:t>
             </a:r>
           </a:p>
         </p:txBody>
@@ -6803,7 +7728,7 @@
           <a:p>
             <a:pPr algn="r"/>
             <a:r>
-              <a:rPr sz="1000">
+              <a:rPr sz="1000" dirty="0">
                 <a:solidFill>
                   <a:srgbClr val="5A5A5A"/>
                 </a:solidFill>
@@ -6818,13 +7743,13 @@
   <p:clrMapOvr>
     <a:masterClrMapping/>
   </p:clrMapOvr>
-  <mc:AlternateContent xmlns:mc="http://schemas.openxmlformats.org/markup-compatibility/2006">
-    <mc:Choice xmlns:p14="http://schemas.microsoft.com/office/powerpoint/2010/main" Requires="p14">
+  <mc:AlternateContent xmlns:mc="http://schemas.openxmlformats.org/markup-compatibility/2006" xmlns:p14="http://schemas.microsoft.com/office/powerpoint/2010/main">
+    <mc:Choice Requires="p14">
       <p:transition spd="med" p14:dur="700">
         <p:fade/>
       </p:transition>
     </mc:Choice>
-    <mc:Fallback>
+    <mc:Fallback xmlns="">
       <p:transition spd="med">
         <p:fade/>
       </p:transition>
@@ -7322,13 +8247,13 @@
   <p:clrMapOvr>
     <a:masterClrMapping/>
   </p:clrMapOvr>
-  <mc:AlternateContent xmlns:mc="http://schemas.openxmlformats.org/markup-compatibility/2006">
-    <mc:Choice xmlns:p14="http://schemas.microsoft.com/office/powerpoint/2010/main" Requires="p14">
+  <mc:AlternateContent xmlns:mc="http://schemas.openxmlformats.org/markup-compatibility/2006" xmlns:p14="http://schemas.microsoft.com/office/powerpoint/2010/main">
+    <mc:Choice Requires="p14">
       <p:transition spd="med" p14:dur="700">
         <p:fade/>
       </p:transition>
     </mc:Choice>
-    <mc:Fallback>
+    <mc:Fallback xmlns="">
       <p:transition spd="med">
         <p:fade/>
       </p:transition>
@@ -7735,7 +8660,7 @@
         <p:spPr>
           <a:xfrm>
             <a:off x="822960" y="1737360"/>
-            <a:ext cx="7315200" cy="3200400"/>
+            <a:ext cx="7850354" cy="1477328"/>
           </a:xfrm>
           <a:prstGeom prst="rect">
             <a:avLst/>
@@ -7748,7 +8673,9 @@
           </a:bodyPr>
           <a:lstStyle/>
           <a:p>
-            <a:pPr>
+            <a:pPr marL="92075" indent="-92075">
+              <a:buFont typeface="Arial" pitchFamily="34" charset="0"/>
+              <a:buChar char="•"/>
               <a:defRPr sz="1800">
                 <a:solidFill>
                   <a:srgbClr val="5A5A5A"/>
@@ -7756,12 +8683,18 @@
               </a:defRPr>
             </a:pPr>
             <a:r>
+              <a:rPr dirty="0" smtClean="0"/>
+              <a:t>Regional </a:t>
+            </a:r>
+            <a:r>
               <a:rPr dirty="0"/>
-              <a:t>• Regional sales variations identified</a:t>
-            </a:r>
-          </a:p>
-          <a:p>
-            <a:pPr>
+              <a:t>sales variations identified</a:t>
+            </a:r>
+          </a:p>
+          <a:p>
+            <a:pPr marL="92075" indent="-92075">
+              <a:buFont typeface="Arial" pitchFamily="34" charset="0"/>
+              <a:buChar char="•"/>
               <a:defRPr sz="1800">
                 <a:solidFill>
                   <a:srgbClr val="5A5A5A"/>
@@ -7769,12 +8702,18 @@
               </a:defRPr>
             </a:pPr>
             <a:r>
+              <a:rPr dirty="0" smtClean="0"/>
+              <a:t>Monthly </a:t>
+            </a:r>
+            <a:r>
               <a:rPr dirty="0"/>
-              <a:t>• Monthly trends analyzed</a:t>
-            </a:r>
-          </a:p>
-          <a:p>
-            <a:pPr>
+              <a:t>trends analyzed</a:t>
+            </a:r>
+          </a:p>
+          <a:p>
+            <a:pPr marL="92075" indent="-92075">
+              <a:buFont typeface="Arial" pitchFamily="34" charset="0"/>
+              <a:buChar char="•"/>
               <a:defRPr sz="1800">
                 <a:solidFill>
                   <a:srgbClr val="5A5A5A"/>
@@ -7782,12 +8721,18 @@
               </a:defRPr>
             </a:pPr>
             <a:r>
+              <a:rPr dirty="0" smtClean="0"/>
+              <a:t>Category </a:t>
+            </a:r>
+            <a:r>
               <a:rPr dirty="0"/>
-              <a:t>• Category profitability evaluated</a:t>
-            </a:r>
-          </a:p>
-          <a:p>
-            <a:pPr>
+              <a:t>profitability evaluated</a:t>
+            </a:r>
+          </a:p>
+          <a:p>
+            <a:pPr marL="92075" indent="-92075">
+              <a:buFont typeface="Arial" pitchFamily="34" charset="0"/>
+              <a:buChar char="•"/>
               <a:defRPr sz="1800">
                 <a:solidFill>
                   <a:srgbClr val="5A5A5A"/>
@@ -7795,8 +8740,31 @@
               </a:defRPr>
             </a:pPr>
             <a:r>
+              <a:rPr dirty="0" smtClean="0"/>
+              <a:t>Top-performing </a:t>
+            </a:r>
+            <a:r>
               <a:rPr dirty="0"/>
-              <a:t>• Top-performing products identified</a:t>
+              <a:t>products identified</a:t>
+            </a:r>
+          </a:p>
+          <a:p>
+            <a:pPr marL="92075" indent="-92075">
+              <a:buFont typeface="Arial" pitchFamily="34" charset="0"/>
+              <a:buChar char="•"/>
+              <a:defRPr sz="1800">
+                <a:solidFill>
+                  <a:srgbClr val="5A5A5A"/>
+                </a:solidFill>
+              </a:defRPr>
+            </a:pPr>
+            <a:r>
+              <a:rPr dirty="0">
+                <a:solidFill>
+                  <a:srgbClr val="5A5A5A"/>
+                </a:solidFill>
+              </a:rPr>
+              <a:t>Pareto product contribution analysis identified major revenue-driving products</a:t>
             </a:r>
           </a:p>
         </p:txBody>
@@ -7873,13 +8841,13 @@
   <p:clrMapOvr>
     <a:masterClrMapping/>
   </p:clrMapOvr>
-  <mc:AlternateContent xmlns:mc="http://schemas.openxmlformats.org/markup-compatibility/2006">
-    <mc:Choice xmlns:p14="http://schemas.microsoft.com/office/powerpoint/2010/main" Requires="p14">
+  <mc:AlternateContent xmlns:mc="http://schemas.openxmlformats.org/markup-compatibility/2006" xmlns:p14="http://schemas.microsoft.com/office/powerpoint/2010/main">
+    <mc:Choice Requires="p14">
       <p:transition spd="med" p14:dur="700">
         <p:fade/>
       </p:transition>
     </mc:Choice>
-    <mc:Fallback>
+    <mc:Fallback xmlns="">
       <p:transition spd="med">
         <p:fade/>
       </p:transition>
@@ -8199,8 +9167,8 @@
         </p:nvSpPr>
         <p:spPr>
           <a:xfrm>
-            <a:off x="822960" y="1737360"/>
-            <a:ext cx="7315200" cy="3200400"/>
+            <a:off x="822960" y="1744491"/>
+            <a:ext cx="3616567" cy="2031325"/>
           </a:xfrm>
           <a:prstGeom prst="rect">
             <a:avLst/>
@@ -8213,7 +9181,9 @@
           </a:bodyPr>
           <a:lstStyle/>
           <a:p>
-            <a:pPr>
+            <a:pPr marL="92075" indent="-92075">
+              <a:buFont typeface="Arial" pitchFamily="34" charset="0"/>
+              <a:buChar char="•"/>
               <a:defRPr sz="1800">
                 <a:solidFill>
                   <a:srgbClr val="5A5A5A"/>
@@ -8221,12 +9191,26 @@
               </a:defRPr>
             </a:pPr>
             <a:r>
+              <a:rPr lang="en-US" dirty="0" smtClean="0"/>
+              <a:t> </a:t>
+            </a:r>
+            <a:r>
+              <a:rPr lang="en-US" dirty="0" smtClean="0"/>
+              <a:t> </a:t>
+            </a:r>
+            <a:r>
+              <a:rPr dirty="0" smtClean="0"/>
+              <a:t>Total </a:t>
+            </a:r>
+            <a:r>
               <a:rPr dirty="0"/>
-              <a:t>• Total Revenue</a:t>
-            </a:r>
-          </a:p>
-          <a:p>
-            <a:pPr>
+              <a:t>Revenue</a:t>
+            </a:r>
+          </a:p>
+          <a:p>
+            <a:pPr marL="92075" indent="-92075">
+              <a:buFont typeface="Arial" pitchFamily="34" charset="0"/>
+              <a:buChar char="•"/>
               <a:defRPr sz="1800">
                 <a:solidFill>
                   <a:srgbClr val="5A5A5A"/>
@@ -8234,12 +9218,26 @@
               </a:defRPr>
             </a:pPr>
             <a:r>
+              <a:rPr lang="en-US" dirty="0" smtClean="0"/>
+              <a:t> </a:t>
+            </a:r>
+            <a:r>
+              <a:rPr lang="en-US" dirty="0" smtClean="0"/>
+              <a:t> </a:t>
+            </a:r>
+            <a:r>
+              <a:rPr dirty="0" smtClean="0"/>
+              <a:t>Total </a:t>
+            </a:r>
+            <a:r>
               <a:rPr dirty="0"/>
-              <a:t>• Total Profit</a:t>
-            </a:r>
-          </a:p>
-          <a:p>
-            <a:pPr>
+              <a:t>Profit</a:t>
+            </a:r>
+          </a:p>
+          <a:p>
+            <a:pPr marL="92075" indent="-92075">
+              <a:buFont typeface="Arial" pitchFamily="34" charset="0"/>
+              <a:buChar char="•"/>
               <a:defRPr sz="1800">
                 <a:solidFill>
                   <a:srgbClr val="5A5A5A"/>
@@ -8247,12 +9245,26 @@
               </a:defRPr>
             </a:pPr>
             <a:r>
+              <a:rPr lang="en-US" dirty="0" smtClean="0"/>
+              <a:t> </a:t>
+            </a:r>
+            <a:r>
+              <a:rPr lang="en-US" dirty="0" smtClean="0"/>
+              <a:t> </a:t>
+            </a:r>
+            <a:r>
+              <a:rPr dirty="0" smtClean="0"/>
+              <a:t>Average </a:t>
+            </a:r>
+            <a:r>
               <a:rPr dirty="0"/>
-              <a:t>• Average Profit Margin</a:t>
-            </a:r>
-          </a:p>
-          <a:p>
-            <a:pPr>
+              <a:t>Profit Margin</a:t>
+            </a:r>
+          </a:p>
+          <a:p>
+            <a:pPr marL="92075" indent="-92075">
+              <a:buFont typeface="Arial" pitchFamily="34" charset="0"/>
+              <a:buChar char="•"/>
               <a:defRPr sz="1800">
                 <a:solidFill>
                   <a:srgbClr val="5A5A5A"/>
@@ -8260,12 +9272,26 @@
               </a:defRPr>
             </a:pPr>
             <a:r>
+              <a:rPr lang="en-US" dirty="0" smtClean="0"/>
+              <a:t> </a:t>
+            </a:r>
+            <a:r>
+              <a:rPr lang="en-US" dirty="0" smtClean="0"/>
+              <a:t> </a:t>
+            </a:r>
+            <a:r>
+              <a:rPr dirty="0" smtClean="0"/>
+              <a:t>Regional </a:t>
+            </a:r>
+            <a:r>
               <a:rPr dirty="0"/>
-              <a:t>• Regional Sales Performance</a:t>
-            </a:r>
-          </a:p>
-          <a:p>
-            <a:pPr>
+              <a:t>Sales Performance</a:t>
+            </a:r>
+          </a:p>
+          <a:p>
+            <a:pPr marL="92075" indent="-92075">
+              <a:buFont typeface="Arial" pitchFamily="34" charset="0"/>
+              <a:buChar char="•"/>
               <a:defRPr sz="1800">
                 <a:solidFill>
                   <a:srgbClr val="5A5A5A"/>
@@ -8273,8 +9299,106 @@
               </a:defRPr>
             </a:pPr>
             <a:r>
+              <a:rPr lang="en-US" dirty="0" smtClean="0"/>
+              <a:t> </a:t>
+            </a:r>
+            <a:r>
+              <a:rPr lang="en-US" dirty="0" smtClean="0"/>
+              <a:t> </a:t>
+            </a:r>
+            <a:r>
+              <a:rPr dirty="0" smtClean="0"/>
+              <a:t>Monthly </a:t>
+            </a:r>
+            <a:r>
               <a:rPr dirty="0"/>
-              <a:t>• Monthly Sales Trends</a:t>
+              <a:t>Sales Trends</a:t>
+            </a:r>
+          </a:p>
+          <a:p>
+            <a:pPr marL="92075" indent="-92075">
+              <a:buFont typeface="Arial" pitchFamily="34" charset="0"/>
+              <a:buChar char="•"/>
+              <a:defRPr sz="1800">
+                <a:solidFill>
+                  <a:srgbClr val="5A5A5A"/>
+                </a:solidFill>
+              </a:defRPr>
+            </a:pPr>
+            <a:r>
+              <a:rPr lang="en-US" dirty="0" smtClean="0">
+                <a:solidFill>
+                  <a:srgbClr val="5A5A5A"/>
+                </a:solidFill>
+              </a:rPr>
+              <a:t> </a:t>
+            </a:r>
+            <a:r>
+              <a:rPr lang="en-US" dirty="0" smtClean="0">
+                <a:solidFill>
+                  <a:srgbClr val="5A5A5A"/>
+                </a:solidFill>
+              </a:rPr>
+              <a:t> </a:t>
+            </a:r>
+            <a:r>
+              <a:rPr dirty="0" smtClean="0">
+                <a:solidFill>
+                  <a:srgbClr val="5A5A5A"/>
+                </a:solidFill>
+              </a:rPr>
+              <a:t>Top </a:t>
+            </a:r>
+            <a:r>
+              <a:rPr dirty="0">
+                <a:solidFill>
+                  <a:srgbClr val="5A5A5A"/>
+                </a:solidFill>
+              </a:rPr>
+              <a:t>Product Revenue Contribution</a:t>
+            </a:r>
+          </a:p>
+          <a:p>
+            <a:pPr marL="92075" indent="-92075">
+              <a:buFont typeface="Arial" pitchFamily="34" charset="0"/>
+              <a:buChar char="•"/>
+              <a:defRPr sz="1800">
+                <a:solidFill>
+                  <a:srgbClr val="5A5A5A"/>
+                </a:solidFill>
+              </a:defRPr>
+            </a:pPr>
+            <a:r>
+              <a:rPr lang="en-US" smtClean="0">
+                <a:solidFill>
+                  <a:srgbClr val="5A5A5A"/>
+                </a:solidFill>
+              </a:rPr>
+              <a:t> </a:t>
+            </a:r>
+            <a:r>
+              <a:rPr lang="en-US" smtClean="0">
+                <a:solidFill>
+                  <a:srgbClr val="5A5A5A"/>
+                </a:solidFill>
+              </a:rPr>
+              <a:t> </a:t>
+            </a:r>
+            <a:r>
+              <a:rPr smtClean="0">
+                <a:solidFill>
+                  <a:srgbClr val="5A5A5A"/>
+                </a:solidFill>
+              </a:rPr>
+              <a:t>Payment </a:t>
+            </a:r>
+            <a:r>
+              <a:rPr dirty="0">
+                <a:solidFill>
+                  <a:srgbClr val="5A5A5A"/>
+                </a:solidFill>
+              </a:rPr>
+              <a:t>Mode Distribution</a:t>
             </a:r>
           </a:p>
         </p:txBody>
@@ -8351,13 +9475,13 @@
   <p:clrMapOvr>
     <a:masterClrMapping/>
   </p:clrMapOvr>
-  <mc:AlternateContent xmlns:mc="http://schemas.openxmlformats.org/markup-compatibility/2006">
-    <mc:Choice xmlns:p14="http://schemas.microsoft.com/office/powerpoint/2010/main" Requires="p14">
+  <mc:AlternateContent xmlns:mc="http://schemas.openxmlformats.org/markup-compatibility/2006" xmlns:p14="http://schemas.microsoft.com/office/powerpoint/2010/main">
+    <mc:Choice Requires="p14">
       <p:transition spd="med" p14:dur="700">
         <p:fade/>
       </p:transition>
     </mc:Choice>
-    <mc:Fallback>
+    <mc:Fallback xmlns="">
       <p:transition spd="med">
         <p:fade/>
       </p:transition>
@@ -8787,8 +9911,8 @@
         </p:nvSpPr>
         <p:spPr>
           <a:xfrm>
-            <a:off x="2377440" y="1645920"/>
-            <a:ext cx="3657600" cy="457200"/>
+            <a:off x="2350478" y="1645920"/>
+            <a:ext cx="2909258" cy="3693319"/>
           </a:xfrm>
           <a:prstGeom prst="rect">
             <a:avLst/>
@@ -8809,68 +9933,31 @@
               </a:defRPr>
             </a:pPr>
             <a:r>
-              <a:rPr dirty="0"/>
+              <a:rPr b="1" dirty="0">
+                <a:solidFill>
+                  <a:srgbClr val="003366"/>
+                </a:solidFill>
+              </a:rPr>
               <a:t>Excel Raw Dataset</a:t>
             </a:r>
           </a:p>
-        </p:txBody>
-      </p:sp>
-      <p:sp>
-        <p:nvSpPr>
-          <p:cNvPr id="8" name="TextBox 7"/>
-          <p:cNvSpPr txBox="1"/>
-          <p:nvPr/>
-        </p:nvSpPr>
-        <p:spPr>
-          <a:xfrm>
-            <a:off x="4023360" y="2029968"/>
-            <a:ext cx="457200" cy="274320"/>
-          </a:xfrm>
-          <a:prstGeom prst="rect">
-            <a:avLst/>
-          </a:prstGeom>
-          <a:noFill/>
-        </p:spPr>
-        <p:txBody>
-          <a:bodyPr wrap="none">
-            <a:spAutoFit/>
-          </a:bodyPr>
-          <a:lstStyle/>
           <a:p>
             <a:pPr algn="ctr">
-              <a:defRPr sz="2000" b="1">
-                <a:solidFill>
-                  <a:srgbClr val="5A5A5A"/>
+              <a:defRPr sz="1800" b="1">
+                <a:solidFill>
+                  <a:srgbClr val="003366"/>
                 </a:solidFill>
               </a:defRPr>
             </a:pPr>
             <a:r>
+              <a:rPr b="1" dirty="0">
+                <a:solidFill>
+                  <a:srgbClr val="003366"/>
+                </a:solidFill>
+              </a:rPr>
               <a:t>↓</a:t>
             </a:r>
           </a:p>
-        </p:txBody>
-      </p:sp>
-      <p:sp>
-        <p:nvSpPr>
-          <p:cNvPr id="9" name="TextBox 8"/>
-          <p:cNvSpPr txBox="1"/>
-          <p:nvPr/>
-        </p:nvSpPr>
-        <p:spPr>
-          <a:xfrm>
-            <a:off x="2377440" y="2286000"/>
-            <a:ext cx="3657600" cy="457200"/>
-          </a:xfrm>
-          <a:prstGeom prst="rect">
-            <a:avLst/>
-          </a:prstGeom>
-          <a:noFill/>
-        </p:spPr>
-        <p:txBody>
-          <a:bodyPr wrap="none">
-            <a:spAutoFit/>
-          </a:bodyPr>
-          <a:lstStyle/>
           <a:p>
             <a:pPr algn="ctr">
               <a:defRPr sz="1800" b="1">
@@ -8880,67 +9967,31 @@
               </a:defRPr>
             </a:pPr>
             <a:r>
+              <a:rPr b="1" dirty="0">
+                <a:solidFill>
+                  <a:srgbClr val="003366"/>
+                </a:solidFill>
+              </a:rPr>
               <a:t>Power Query ETL</a:t>
             </a:r>
           </a:p>
-        </p:txBody>
-      </p:sp>
-      <p:sp>
-        <p:nvSpPr>
-          <p:cNvPr id="10" name="TextBox 9"/>
-          <p:cNvSpPr txBox="1"/>
-          <p:nvPr/>
-        </p:nvSpPr>
-        <p:spPr>
-          <a:xfrm>
-            <a:off x="4023360" y="2670048"/>
-            <a:ext cx="457200" cy="274320"/>
-          </a:xfrm>
-          <a:prstGeom prst="rect">
-            <a:avLst/>
-          </a:prstGeom>
-          <a:noFill/>
-        </p:spPr>
-        <p:txBody>
-          <a:bodyPr wrap="none">
-            <a:spAutoFit/>
-          </a:bodyPr>
-          <a:lstStyle/>
           <a:p>
             <a:pPr algn="ctr">
-              <a:defRPr sz="2000" b="1">
-                <a:solidFill>
-                  <a:srgbClr val="5A5A5A"/>
+              <a:defRPr sz="1800" b="1">
+                <a:solidFill>
+                  <a:srgbClr val="003366"/>
                 </a:solidFill>
               </a:defRPr>
             </a:pPr>
             <a:r>
+              <a:rPr b="1" dirty="0">
+                <a:solidFill>
+                  <a:srgbClr val="003366"/>
+                </a:solidFill>
+              </a:rPr>
               <a:t>↓</a:t>
             </a:r>
           </a:p>
-        </p:txBody>
-      </p:sp>
-      <p:sp>
-        <p:nvSpPr>
-          <p:cNvPr id="11" name="TextBox 10"/>
-          <p:cNvSpPr txBox="1"/>
-          <p:nvPr/>
-        </p:nvSpPr>
-        <p:spPr>
-          <a:xfrm>
-            <a:off x="2377440" y="2926080"/>
-            <a:ext cx="3657600" cy="457200"/>
-          </a:xfrm>
-          <a:prstGeom prst="rect">
-            <a:avLst/>
-          </a:prstGeom>
-          <a:noFill/>
-        </p:spPr>
-        <p:txBody>
-          <a:bodyPr wrap="none">
-            <a:spAutoFit/>
-          </a:bodyPr>
-          <a:lstStyle/>
           <a:p>
             <a:pPr algn="ctr">
               <a:defRPr sz="1800" b="1">
@@ -8950,67 +10001,31 @@
               </a:defRPr>
             </a:pPr>
             <a:r>
+              <a:rPr b="1" dirty="0">
+                <a:solidFill>
+                  <a:srgbClr val="003366"/>
+                </a:solidFill>
+              </a:rPr>
               <a:t>Cleaned Dataset</a:t>
             </a:r>
           </a:p>
-        </p:txBody>
-      </p:sp>
-      <p:sp>
-        <p:nvSpPr>
-          <p:cNvPr id="12" name="TextBox 11"/>
-          <p:cNvSpPr txBox="1"/>
-          <p:nvPr/>
-        </p:nvSpPr>
-        <p:spPr>
-          <a:xfrm>
-            <a:off x="4023360" y="3310128"/>
-            <a:ext cx="457200" cy="274320"/>
-          </a:xfrm>
-          <a:prstGeom prst="rect">
-            <a:avLst/>
-          </a:prstGeom>
-          <a:noFill/>
-        </p:spPr>
-        <p:txBody>
-          <a:bodyPr wrap="none">
-            <a:spAutoFit/>
-          </a:bodyPr>
-          <a:lstStyle/>
           <a:p>
             <a:pPr algn="ctr">
-              <a:defRPr sz="2000" b="1">
-                <a:solidFill>
-                  <a:srgbClr val="5A5A5A"/>
+              <a:defRPr sz="1800" b="1">
+                <a:solidFill>
+                  <a:srgbClr val="003366"/>
                 </a:solidFill>
               </a:defRPr>
             </a:pPr>
             <a:r>
+              <a:rPr b="1" dirty="0">
+                <a:solidFill>
+                  <a:srgbClr val="003366"/>
+                </a:solidFill>
+              </a:rPr>
               <a:t>↓</a:t>
             </a:r>
           </a:p>
-        </p:txBody>
-      </p:sp>
-      <p:sp>
-        <p:nvSpPr>
-          <p:cNvPr id="13" name="TextBox 12"/>
-          <p:cNvSpPr txBox="1"/>
-          <p:nvPr/>
-        </p:nvSpPr>
-        <p:spPr>
-          <a:xfrm>
-            <a:off x="2377440" y="3566159"/>
-            <a:ext cx="3657600" cy="457200"/>
-          </a:xfrm>
-          <a:prstGeom prst="rect">
-            <a:avLst/>
-          </a:prstGeom>
-          <a:noFill/>
-        </p:spPr>
-        <p:txBody>
-          <a:bodyPr wrap="none">
-            <a:spAutoFit/>
-          </a:bodyPr>
-          <a:lstStyle/>
           <a:p>
             <a:pPr algn="ctr">
               <a:defRPr sz="1800" b="1">
@@ -9020,67 +10035,39 @@
               </a:defRPr>
             </a:pPr>
             <a:r>
-              <a:t>Dockerized MySQL</a:t>
-            </a:r>
-          </a:p>
-        </p:txBody>
-      </p:sp>
-      <p:sp>
-        <p:nvSpPr>
-          <p:cNvPr id="14" name="TextBox 13"/>
-          <p:cNvSpPr txBox="1"/>
-          <p:nvPr/>
-        </p:nvSpPr>
-        <p:spPr>
-          <a:xfrm>
-            <a:off x="4023360" y="3950208"/>
-            <a:ext cx="457200" cy="274320"/>
-          </a:xfrm>
-          <a:prstGeom prst="rect">
-            <a:avLst/>
-          </a:prstGeom>
-          <a:noFill/>
-        </p:spPr>
-        <p:txBody>
-          <a:bodyPr wrap="none">
-            <a:spAutoFit/>
-          </a:bodyPr>
-          <a:lstStyle/>
+              <a:rPr b="1" dirty="0" err="1">
+                <a:solidFill>
+                  <a:srgbClr val="003366"/>
+                </a:solidFill>
+              </a:rPr>
+              <a:t>Dockerized</a:t>
+            </a:r>
+            <a:r>
+              <a:rPr b="1" dirty="0">
+                <a:solidFill>
+                  <a:srgbClr val="003366"/>
+                </a:solidFill>
+              </a:rPr>
+              <a:t> MySQL Database</a:t>
+            </a:r>
+          </a:p>
           <a:p>
             <a:pPr algn="ctr">
-              <a:defRPr sz="2000" b="1">
-                <a:solidFill>
-                  <a:srgbClr val="5A5A5A"/>
+              <a:defRPr sz="1800" b="1">
+                <a:solidFill>
+                  <a:srgbClr val="003366"/>
                 </a:solidFill>
               </a:defRPr>
             </a:pPr>
             <a:r>
+              <a:rPr b="1" dirty="0">
+                <a:solidFill>
+                  <a:srgbClr val="003366"/>
+                </a:solidFill>
+              </a:rPr>
               <a:t>↓</a:t>
             </a:r>
           </a:p>
-        </p:txBody>
-      </p:sp>
-      <p:sp>
-        <p:nvSpPr>
-          <p:cNvPr id="15" name="TextBox 14"/>
-          <p:cNvSpPr txBox="1"/>
-          <p:nvPr/>
-        </p:nvSpPr>
-        <p:spPr>
-          <a:xfrm>
-            <a:off x="2377440" y="4206240"/>
-            <a:ext cx="3657600" cy="457200"/>
-          </a:xfrm>
-          <a:prstGeom prst="rect">
-            <a:avLst/>
-          </a:prstGeom>
-          <a:noFill/>
-        </p:spPr>
-        <p:txBody>
-          <a:bodyPr wrap="none">
-            <a:spAutoFit/>
-          </a:bodyPr>
-          <a:lstStyle/>
           <a:p>
             <a:pPr algn="ctr">
               <a:defRPr sz="1800" b="1">
@@ -9090,67 +10077,31 @@
               </a:defRPr>
             </a:pPr>
             <a:r>
-              <a:t>SQL KPI Analytics</a:t>
-            </a:r>
-          </a:p>
-        </p:txBody>
-      </p:sp>
-      <p:sp>
-        <p:nvSpPr>
-          <p:cNvPr id="16" name="TextBox 15"/>
-          <p:cNvSpPr txBox="1"/>
-          <p:nvPr/>
-        </p:nvSpPr>
-        <p:spPr>
-          <a:xfrm>
-            <a:off x="4023360" y="4590288"/>
-            <a:ext cx="457200" cy="274320"/>
-          </a:xfrm>
-          <a:prstGeom prst="rect">
-            <a:avLst/>
-          </a:prstGeom>
-          <a:noFill/>
-        </p:spPr>
-        <p:txBody>
-          <a:bodyPr wrap="none">
-            <a:spAutoFit/>
-          </a:bodyPr>
-          <a:lstStyle/>
+              <a:rPr b="1" dirty="0">
+                <a:solidFill>
+                  <a:srgbClr val="003366"/>
+                </a:solidFill>
+              </a:rPr>
+              <a:t>SQL Reporting and Analytics</a:t>
+            </a:r>
+          </a:p>
           <a:p>
             <a:pPr algn="ctr">
-              <a:defRPr sz="2000" b="1">
-                <a:solidFill>
-                  <a:srgbClr val="5A5A5A"/>
+              <a:defRPr sz="1800" b="1">
+                <a:solidFill>
+                  <a:srgbClr val="003366"/>
                 </a:solidFill>
               </a:defRPr>
             </a:pPr>
             <a:r>
+              <a:rPr b="1" dirty="0">
+                <a:solidFill>
+                  <a:srgbClr val="003366"/>
+                </a:solidFill>
+              </a:rPr>
               <a:t>↓</a:t>
             </a:r>
           </a:p>
-        </p:txBody>
-      </p:sp>
-      <p:sp>
-        <p:nvSpPr>
-          <p:cNvPr id="17" name="TextBox 16"/>
-          <p:cNvSpPr txBox="1"/>
-          <p:nvPr/>
-        </p:nvSpPr>
-        <p:spPr>
-          <a:xfrm>
-            <a:off x="2377440" y="4846320"/>
-            <a:ext cx="3657600" cy="457200"/>
-          </a:xfrm>
-          <a:prstGeom prst="rect">
-            <a:avLst/>
-          </a:prstGeom>
-          <a:noFill/>
-        </p:spPr>
-        <p:txBody>
-          <a:bodyPr wrap="none">
-            <a:spAutoFit/>
-          </a:bodyPr>
-          <a:lstStyle/>
           <a:p>
             <a:pPr algn="ctr">
               <a:defRPr sz="1800" b="1">
@@ -9160,7 +10111,46 @@
               </a:defRPr>
             </a:pPr>
             <a:r>
-              <a:t>Tableau Dashboard</a:t>
+              <a:rPr b="1" dirty="0">
+                <a:solidFill>
+                  <a:srgbClr val="003366"/>
+                </a:solidFill>
+              </a:rPr>
+              <a:t>Advanced Analytics</a:t>
+            </a:r>
+          </a:p>
+          <a:p>
+            <a:pPr algn="ctr">
+              <a:defRPr sz="1800" b="1">
+                <a:solidFill>
+                  <a:srgbClr val="003366"/>
+                </a:solidFill>
+              </a:defRPr>
+            </a:pPr>
+            <a:r>
+              <a:rPr b="1" dirty="0">
+                <a:solidFill>
+                  <a:srgbClr val="003366"/>
+                </a:solidFill>
+              </a:rPr>
+              <a:t>↓</a:t>
+            </a:r>
+          </a:p>
+          <a:p>
+            <a:pPr algn="ctr">
+              <a:defRPr sz="1800" b="1">
+                <a:solidFill>
+                  <a:srgbClr val="003366"/>
+                </a:solidFill>
+              </a:defRPr>
+            </a:pPr>
+            <a:r>
+              <a:rPr b="1" dirty="0">
+                <a:solidFill>
+                  <a:srgbClr val="003366"/>
+                </a:solidFill>
+              </a:rPr>
+              <a:t>Tableau KPI Dashboard</a:t>
             </a:r>
           </a:p>
         </p:txBody>
@@ -9170,13 +10160,13 @@
   <p:clrMapOvr>
     <a:masterClrMapping/>
   </p:clrMapOvr>
-  <mc:AlternateContent xmlns:mc="http://schemas.openxmlformats.org/markup-compatibility/2006">
-    <mc:Choice xmlns:p14="http://schemas.microsoft.com/office/powerpoint/2010/main" Requires="p14">
+  <mc:AlternateContent xmlns:mc="http://schemas.openxmlformats.org/markup-compatibility/2006" xmlns:p14="http://schemas.microsoft.com/office/powerpoint/2010/main">
+    <mc:Choice Requires="p14">
       <p:transition spd="med" p14:dur="700">
         <p:fade/>
       </p:transition>
     </mc:Choice>
-    <mc:Fallback>
+    <mc:Fallback xmlns="">
       <p:transition spd="med">
         <p:fade/>
       </p:transition>

</xml_diff>